<commit_message>
Atualizando projeto no novo diretorio Mochila01
</commit_message>
<xml_diff>
--- a/Mochila01_MetaHeuristicas_TabuVsAG.pptx
+++ b/Mochila01_MetaHeuristicas_TabuVsAG.pptx
@@ -5,20 +5,20 @@
     <p:sldMasterId id="2147483648" r:id="rId1"/>
   </p:sldMasterIdLst>
   <p:sldIdLst>
-    <p:sldId id="256" r:id="rId7"/>
-    <p:sldId id="257" r:id="rId8"/>
-    <p:sldId id="258" r:id="rId9"/>
-    <p:sldId id="259" r:id="rId10"/>
-    <p:sldId id="260" r:id="rId11"/>
-    <p:sldId id="261" r:id="rId12"/>
-    <p:sldId id="262" r:id="rId13"/>
-    <p:sldId id="263" r:id="rId14"/>
-    <p:sldId id="264" r:id="rId15"/>
-    <p:sldId id="265" r:id="rId16"/>
-    <p:sldId id="266" r:id="rId17"/>
-    <p:sldId id="267" r:id="rId18"/>
+    <p:sldId id="256" r:id="rId2"/>
+    <p:sldId id="257" r:id="rId3"/>
+    <p:sldId id="258" r:id="rId4"/>
+    <p:sldId id="259" r:id="rId5"/>
+    <p:sldId id="260" r:id="rId6"/>
+    <p:sldId id="261" r:id="rId7"/>
+    <p:sldId id="262" r:id="rId8"/>
+    <p:sldId id="263" r:id="rId9"/>
+    <p:sldId id="264" r:id="rId10"/>
+    <p:sldId id="265" r:id="rId11"/>
+    <p:sldId id="266" r:id="rId12"/>
+    <p:sldId id="267" r:id="rId13"/>
   </p:sldIdLst>
-  <p:sldSz cx="12191695" cy="6858000" type="screen4x3"/>
+  <p:sldSz cx="12192000" cy="6858000"/>
   <p:notesSz cx="6858000" cy="9144000"/>
   <p:defaultTextStyle>
     <a:defPPr>
@@ -115,6 +115,22 @@
       </a:defRPr>
     </a:lvl9pPr>
   </p:defaultTextStyle>
+  <p:extLst>
+    <p:ext uri="{EFAFB233-063F-42B5-8137-9DF3F51BA10A}">
+      <p15:sldGuideLst xmlns:p15="http://schemas.microsoft.com/office/powerpoint/2012/main">
+        <p15:guide id="1" orient="horz" pos="2160">
+          <p15:clr>
+            <a:srgbClr val="A4A3A4"/>
+          </p15:clr>
+        </p15:guide>
+        <p15:guide id="2" pos="2880">
+          <p15:clr>
+            <a:srgbClr val="A4A3A4"/>
+          </p15:clr>
+        </p15:guide>
+      </p15:sldGuideLst>
+    </p:ext>
+  </p:extLst>
 </p:presentation>
 </file>
 
@@ -156,10 +172,9 @@
           <a:lstStyle/>
           <a:p>
             <a:r>
-              <a:rPr lang="en-US" smtClean="0"/>
+              <a:rPr lang="en-US"/>
               <a:t>Click to edit Master title style</a:t>
             </a:r>
-            <a:endParaRPr lang="en-US"/>
           </a:p>
         </p:txBody>
       </p:sp>
@@ -275,10 +290,9 @@
           </a:lstStyle>
           <a:p>
             <a:r>
-              <a:rPr lang="en-US" smtClean="0"/>
+              <a:rPr lang="en-US"/>
               <a:t>Click to edit Master subtitle style</a:t>
             </a:r>
-            <a:endParaRPr lang="en-US"/>
           </a:p>
         </p:txBody>
       </p:sp>
@@ -299,7 +313,7 @@
           <a:p>
             <a:fld id="{5BCAD085-E8A6-8845-BD4E-CB4CCA059FC4}" type="datetimeFigureOut">
               <a:rPr lang="en-US" smtClean="0"/>
-              <a:t>1/27/13</a:t>
+              <a:t>9/20/2026</a:t>
             </a:fld>
             <a:endParaRPr lang="en-US"/>
           </a:p>
@@ -341,7 +355,7 @@
           <a:p>
             <a:fld id="{C1FF6DA9-008F-8B48-92A6-B652298478BF}" type="slidenum">
               <a:rPr lang="en-US" smtClean="0"/>
-              <a:t>‹#›</a:t>
+              <a:t>‹nº›</a:t>
             </a:fld>
             <a:endParaRPr lang="en-US"/>
           </a:p>
@@ -393,10 +407,9 @@
           <a:lstStyle/>
           <a:p>
             <a:r>
-              <a:rPr lang="en-US" smtClean="0"/>
+              <a:rPr lang="en-US"/>
               <a:t>Click to edit Master title style</a:t>
             </a:r>
-            <a:endParaRPr lang="en-US"/>
           </a:p>
         </p:txBody>
       </p:sp>
@@ -417,38 +430,37 @@
           <a:p>
             <a:pPr lvl="0"/>
             <a:r>
-              <a:rPr lang="en-US" smtClean="0"/>
+              <a:rPr lang="en-US"/>
               <a:t>Click to edit Master text styles</a:t>
             </a:r>
           </a:p>
           <a:p>
             <a:pPr lvl="1"/>
             <a:r>
-              <a:rPr lang="en-US" smtClean="0"/>
+              <a:rPr lang="en-US"/>
               <a:t>Second level</a:t>
             </a:r>
           </a:p>
           <a:p>
             <a:pPr lvl="2"/>
             <a:r>
-              <a:rPr lang="en-US" smtClean="0"/>
+              <a:rPr lang="en-US"/>
               <a:t>Third level</a:t>
             </a:r>
           </a:p>
           <a:p>
             <a:pPr lvl="3"/>
             <a:r>
-              <a:rPr lang="en-US" smtClean="0"/>
+              <a:rPr lang="en-US"/>
               <a:t>Fourth level</a:t>
             </a:r>
           </a:p>
           <a:p>
             <a:pPr lvl="4"/>
             <a:r>
-              <a:rPr lang="en-US" smtClean="0"/>
+              <a:rPr lang="en-US"/>
               <a:t>Fifth level</a:t>
             </a:r>
-            <a:endParaRPr lang="en-US"/>
           </a:p>
         </p:txBody>
       </p:sp>
@@ -469,7 +481,7 @@
           <a:p>
             <a:fld id="{5BCAD085-E8A6-8845-BD4E-CB4CCA059FC4}" type="datetimeFigureOut">
               <a:rPr lang="en-US" smtClean="0"/>
-              <a:t>1/27/13</a:t>
+              <a:t>9/20/2026</a:t>
             </a:fld>
             <a:endParaRPr lang="en-US"/>
           </a:p>
@@ -511,7 +523,7 @@
           <a:p>
             <a:fld id="{C1FF6DA9-008F-8B48-92A6-B652298478BF}" type="slidenum">
               <a:rPr lang="en-US" smtClean="0"/>
-              <a:t>‹#›</a:t>
+              <a:t>‹nº›</a:t>
             </a:fld>
             <a:endParaRPr lang="en-US"/>
           </a:p>
@@ -568,10 +580,9 @@
           <a:lstStyle/>
           <a:p>
             <a:r>
-              <a:rPr lang="en-US" smtClean="0"/>
+              <a:rPr lang="en-US"/>
               <a:t>Click to edit Master title style</a:t>
             </a:r>
-            <a:endParaRPr lang="en-US"/>
           </a:p>
         </p:txBody>
       </p:sp>
@@ -597,38 +608,37 @@
           <a:p>
             <a:pPr lvl="0"/>
             <a:r>
-              <a:rPr lang="en-US" smtClean="0"/>
+              <a:rPr lang="en-US"/>
               <a:t>Click to edit Master text styles</a:t>
             </a:r>
           </a:p>
           <a:p>
             <a:pPr lvl="1"/>
             <a:r>
-              <a:rPr lang="en-US" smtClean="0"/>
+              <a:rPr lang="en-US"/>
               <a:t>Second level</a:t>
             </a:r>
           </a:p>
           <a:p>
             <a:pPr lvl="2"/>
             <a:r>
-              <a:rPr lang="en-US" smtClean="0"/>
+              <a:rPr lang="en-US"/>
               <a:t>Third level</a:t>
             </a:r>
           </a:p>
           <a:p>
             <a:pPr lvl="3"/>
             <a:r>
-              <a:rPr lang="en-US" smtClean="0"/>
+              <a:rPr lang="en-US"/>
               <a:t>Fourth level</a:t>
             </a:r>
           </a:p>
           <a:p>
             <a:pPr lvl="4"/>
             <a:r>
-              <a:rPr lang="en-US" smtClean="0"/>
+              <a:rPr lang="en-US"/>
               <a:t>Fifth level</a:t>
             </a:r>
-            <a:endParaRPr lang="en-US"/>
           </a:p>
         </p:txBody>
       </p:sp>
@@ -649,7 +659,7 @@
           <a:p>
             <a:fld id="{5BCAD085-E8A6-8845-BD4E-CB4CCA059FC4}" type="datetimeFigureOut">
               <a:rPr lang="en-US" smtClean="0"/>
-              <a:t>1/27/13</a:t>
+              <a:t>9/20/2026</a:t>
             </a:fld>
             <a:endParaRPr lang="en-US"/>
           </a:p>
@@ -691,7 +701,7 @@
           <a:p>
             <a:fld id="{C1FF6DA9-008F-8B48-92A6-B652298478BF}" type="slidenum">
               <a:rPr lang="en-US" smtClean="0"/>
-              <a:t>‹#›</a:t>
+              <a:t>‹nº›</a:t>
             </a:fld>
             <a:endParaRPr lang="en-US"/>
           </a:p>
@@ -743,10 +753,9 @@
           <a:lstStyle/>
           <a:p>
             <a:r>
-              <a:rPr lang="en-US" smtClean="0"/>
+              <a:rPr lang="en-US"/>
               <a:t>Click to edit Master title style</a:t>
             </a:r>
-            <a:endParaRPr lang="en-US"/>
           </a:p>
         </p:txBody>
       </p:sp>
@@ -767,38 +776,37 @@
           <a:p>
             <a:pPr lvl="0"/>
             <a:r>
-              <a:rPr lang="en-US" smtClean="0"/>
+              <a:rPr lang="en-US"/>
               <a:t>Click to edit Master text styles</a:t>
             </a:r>
           </a:p>
           <a:p>
             <a:pPr lvl="1"/>
             <a:r>
-              <a:rPr lang="en-US" smtClean="0"/>
+              <a:rPr lang="en-US"/>
               <a:t>Second level</a:t>
             </a:r>
           </a:p>
           <a:p>
             <a:pPr lvl="2"/>
             <a:r>
-              <a:rPr lang="en-US" smtClean="0"/>
+              <a:rPr lang="en-US"/>
               <a:t>Third level</a:t>
             </a:r>
           </a:p>
           <a:p>
             <a:pPr lvl="3"/>
             <a:r>
-              <a:rPr lang="en-US" smtClean="0"/>
+              <a:rPr lang="en-US"/>
               <a:t>Fourth level</a:t>
             </a:r>
           </a:p>
           <a:p>
             <a:pPr lvl="4"/>
             <a:r>
-              <a:rPr lang="en-US" smtClean="0"/>
+              <a:rPr lang="en-US"/>
               <a:t>Fifth level</a:t>
             </a:r>
-            <a:endParaRPr lang="en-US"/>
           </a:p>
         </p:txBody>
       </p:sp>
@@ -819,7 +827,7 @@
           <a:p>
             <a:fld id="{5BCAD085-E8A6-8845-BD4E-CB4CCA059FC4}" type="datetimeFigureOut">
               <a:rPr lang="en-US" smtClean="0"/>
-              <a:t>1/27/13</a:t>
+              <a:t>9/20/2026</a:t>
             </a:fld>
             <a:endParaRPr lang="en-US"/>
           </a:p>
@@ -861,7 +869,7 @@
           <a:p>
             <a:fld id="{C1FF6DA9-008F-8B48-92A6-B652298478BF}" type="slidenum">
               <a:rPr lang="en-US" smtClean="0"/>
-              <a:t>‹#›</a:t>
+              <a:t>‹nº›</a:t>
             </a:fld>
             <a:endParaRPr lang="en-US"/>
           </a:p>
@@ -922,10 +930,9 @@
           </a:lstStyle>
           <a:p>
             <a:r>
-              <a:rPr lang="en-US" smtClean="0"/>
+              <a:rPr lang="en-US"/>
               <a:t>Click to edit Master title style</a:t>
             </a:r>
-            <a:endParaRPr lang="en-US"/>
           </a:p>
         </p:txBody>
       </p:sp>
@@ -1042,7 +1049,7 @@
           <a:p>
             <a:pPr lvl="0"/>
             <a:r>
-              <a:rPr lang="en-US" smtClean="0"/>
+              <a:rPr lang="en-US"/>
               <a:t>Click to edit Master text styles</a:t>
             </a:r>
           </a:p>
@@ -1065,7 +1072,7 @@
           <a:p>
             <a:fld id="{5BCAD085-E8A6-8845-BD4E-CB4CCA059FC4}" type="datetimeFigureOut">
               <a:rPr lang="en-US" smtClean="0"/>
-              <a:t>1/27/13</a:t>
+              <a:t>9/20/2026</a:t>
             </a:fld>
             <a:endParaRPr lang="en-US"/>
           </a:p>
@@ -1107,7 +1114,7 @@
           <a:p>
             <a:fld id="{C1FF6DA9-008F-8B48-92A6-B652298478BF}" type="slidenum">
               <a:rPr lang="en-US" smtClean="0"/>
-              <a:t>‹#›</a:t>
+              <a:t>‹nº›</a:t>
             </a:fld>
             <a:endParaRPr lang="en-US"/>
           </a:p>
@@ -1159,10 +1166,9 @@
           <a:lstStyle/>
           <a:p>
             <a:r>
-              <a:rPr lang="en-US" smtClean="0"/>
+              <a:rPr lang="en-US"/>
               <a:t>Click to edit Master title style</a:t>
             </a:r>
-            <a:endParaRPr lang="en-US"/>
           </a:p>
         </p:txBody>
       </p:sp>
@@ -1216,38 +1222,37 @@
           <a:p>
             <a:pPr lvl="0"/>
             <a:r>
-              <a:rPr lang="en-US" smtClean="0"/>
+              <a:rPr lang="en-US"/>
               <a:t>Click to edit Master text styles</a:t>
             </a:r>
           </a:p>
           <a:p>
             <a:pPr lvl="1"/>
             <a:r>
-              <a:rPr lang="en-US" smtClean="0"/>
+              <a:rPr lang="en-US"/>
               <a:t>Second level</a:t>
             </a:r>
           </a:p>
           <a:p>
             <a:pPr lvl="2"/>
             <a:r>
-              <a:rPr lang="en-US" smtClean="0"/>
+              <a:rPr lang="en-US"/>
               <a:t>Third level</a:t>
             </a:r>
           </a:p>
           <a:p>
             <a:pPr lvl="3"/>
             <a:r>
-              <a:rPr lang="en-US" smtClean="0"/>
+              <a:rPr lang="en-US"/>
               <a:t>Fourth level</a:t>
             </a:r>
           </a:p>
           <a:p>
             <a:pPr lvl="4"/>
             <a:r>
-              <a:rPr lang="en-US" smtClean="0"/>
+              <a:rPr lang="en-US"/>
               <a:t>Fifth level</a:t>
             </a:r>
-            <a:endParaRPr lang="en-US"/>
           </a:p>
         </p:txBody>
       </p:sp>
@@ -1301,38 +1306,37 @@
           <a:p>
             <a:pPr lvl="0"/>
             <a:r>
-              <a:rPr lang="en-US" smtClean="0"/>
+              <a:rPr lang="en-US"/>
               <a:t>Click to edit Master text styles</a:t>
             </a:r>
           </a:p>
           <a:p>
             <a:pPr lvl="1"/>
             <a:r>
-              <a:rPr lang="en-US" smtClean="0"/>
+              <a:rPr lang="en-US"/>
               <a:t>Second level</a:t>
             </a:r>
           </a:p>
           <a:p>
             <a:pPr lvl="2"/>
             <a:r>
-              <a:rPr lang="en-US" smtClean="0"/>
+              <a:rPr lang="en-US"/>
               <a:t>Third level</a:t>
             </a:r>
           </a:p>
           <a:p>
             <a:pPr lvl="3"/>
             <a:r>
-              <a:rPr lang="en-US" smtClean="0"/>
+              <a:rPr lang="en-US"/>
               <a:t>Fourth level</a:t>
             </a:r>
           </a:p>
           <a:p>
             <a:pPr lvl="4"/>
             <a:r>
-              <a:rPr lang="en-US" smtClean="0"/>
+              <a:rPr lang="en-US"/>
               <a:t>Fifth level</a:t>
             </a:r>
-            <a:endParaRPr lang="en-US"/>
           </a:p>
         </p:txBody>
       </p:sp>
@@ -1353,7 +1357,7 @@
           <a:p>
             <a:fld id="{5BCAD085-E8A6-8845-BD4E-CB4CCA059FC4}" type="datetimeFigureOut">
               <a:rPr lang="en-US" smtClean="0"/>
-              <a:t>1/27/13</a:t>
+              <a:t>9/20/2026</a:t>
             </a:fld>
             <a:endParaRPr lang="en-US"/>
           </a:p>
@@ -1395,7 +1399,7 @@
           <a:p>
             <a:fld id="{C1FF6DA9-008F-8B48-92A6-B652298478BF}" type="slidenum">
               <a:rPr lang="en-US" smtClean="0"/>
-              <a:t>‹#›</a:t>
+              <a:t>‹nº›</a:t>
             </a:fld>
             <a:endParaRPr lang="en-US"/>
           </a:p>
@@ -1451,10 +1455,9 @@
           </a:lstStyle>
           <a:p>
             <a:r>
-              <a:rPr lang="en-US" smtClean="0"/>
+              <a:rPr lang="en-US"/>
               <a:t>Click to edit Master title style</a:t>
             </a:r>
-            <a:endParaRPr lang="en-US"/>
           </a:p>
         </p:txBody>
       </p:sp>
@@ -1517,7 +1520,7 @@
           <a:p>
             <a:pPr lvl="0"/>
             <a:r>
-              <a:rPr lang="en-US" smtClean="0"/>
+              <a:rPr lang="en-US"/>
               <a:t>Click to edit Master text styles</a:t>
             </a:r>
           </a:p>
@@ -1573,38 +1576,37 @@
           <a:p>
             <a:pPr lvl="0"/>
             <a:r>
-              <a:rPr lang="en-US" smtClean="0"/>
+              <a:rPr lang="en-US"/>
               <a:t>Click to edit Master text styles</a:t>
             </a:r>
           </a:p>
           <a:p>
             <a:pPr lvl="1"/>
             <a:r>
-              <a:rPr lang="en-US" smtClean="0"/>
+              <a:rPr lang="en-US"/>
               <a:t>Second level</a:t>
             </a:r>
           </a:p>
           <a:p>
             <a:pPr lvl="2"/>
             <a:r>
-              <a:rPr lang="en-US" smtClean="0"/>
+              <a:rPr lang="en-US"/>
               <a:t>Third level</a:t>
             </a:r>
           </a:p>
           <a:p>
             <a:pPr lvl="3"/>
             <a:r>
-              <a:rPr lang="en-US" smtClean="0"/>
+              <a:rPr lang="en-US"/>
               <a:t>Fourth level</a:t>
             </a:r>
           </a:p>
           <a:p>
             <a:pPr lvl="4"/>
             <a:r>
-              <a:rPr lang="en-US" smtClean="0"/>
+              <a:rPr lang="en-US"/>
               <a:t>Fifth level</a:t>
             </a:r>
-            <a:endParaRPr lang="en-US"/>
           </a:p>
         </p:txBody>
       </p:sp>
@@ -1667,7 +1669,7 @@
           <a:p>
             <a:pPr lvl="0"/>
             <a:r>
-              <a:rPr lang="en-US" smtClean="0"/>
+              <a:rPr lang="en-US"/>
               <a:t>Click to edit Master text styles</a:t>
             </a:r>
           </a:p>
@@ -1723,38 +1725,37 @@
           <a:p>
             <a:pPr lvl="0"/>
             <a:r>
-              <a:rPr lang="en-US" smtClean="0"/>
+              <a:rPr lang="en-US"/>
               <a:t>Click to edit Master text styles</a:t>
             </a:r>
           </a:p>
           <a:p>
             <a:pPr lvl="1"/>
             <a:r>
-              <a:rPr lang="en-US" smtClean="0"/>
+              <a:rPr lang="en-US"/>
               <a:t>Second level</a:t>
             </a:r>
           </a:p>
           <a:p>
             <a:pPr lvl="2"/>
             <a:r>
-              <a:rPr lang="en-US" smtClean="0"/>
+              <a:rPr lang="en-US"/>
               <a:t>Third level</a:t>
             </a:r>
           </a:p>
           <a:p>
             <a:pPr lvl="3"/>
             <a:r>
-              <a:rPr lang="en-US" smtClean="0"/>
+              <a:rPr lang="en-US"/>
               <a:t>Fourth level</a:t>
             </a:r>
           </a:p>
           <a:p>
             <a:pPr lvl="4"/>
             <a:r>
-              <a:rPr lang="en-US" smtClean="0"/>
+              <a:rPr lang="en-US"/>
               <a:t>Fifth level</a:t>
             </a:r>
-            <a:endParaRPr lang="en-US"/>
           </a:p>
         </p:txBody>
       </p:sp>
@@ -1775,7 +1776,7 @@
           <a:p>
             <a:fld id="{5BCAD085-E8A6-8845-BD4E-CB4CCA059FC4}" type="datetimeFigureOut">
               <a:rPr lang="en-US" smtClean="0"/>
-              <a:t>1/27/13</a:t>
+              <a:t>9/20/2026</a:t>
             </a:fld>
             <a:endParaRPr lang="en-US"/>
           </a:p>
@@ -1817,7 +1818,7 @@
           <a:p>
             <a:fld id="{C1FF6DA9-008F-8B48-92A6-B652298478BF}" type="slidenum">
               <a:rPr lang="en-US" smtClean="0"/>
-              <a:t>‹#›</a:t>
+              <a:t>‹nº›</a:t>
             </a:fld>
             <a:endParaRPr lang="en-US"/>
           </a:p>
@@ -1869,10 +1870,9 @@
           <a:lstStyle/>
           <a:p>
             <a:r>
-              <a:rPr lang="en-US" smtClean="0"/>
+              <a:rPr lang="en-US"/>
               <a:t>Click to edit Master title style</a:t>
             </a:r>
-            <a:endParaRPr lang="en-US"/>
           </a:p>
         </p:txBody>
       </p:sp>
@@ -1893,7 +1893,7 @@
           <a:p>
             <a:fld id="{5BCAD085-E8A6-8845-BD4E-CB4CCA059FC4}" type="datetimeFigureOut">
               <a:rPr lang="en-US" smtClean="0"/>
-              <a:t>1/27/13</a:t>
+              <a:t>9/20/2026</a:t>
             </a:fld>
             <a:endParaRPr lang="en-US"/>
           </a:p>
@@ -1935,7 +1935,7 @@
           <a:p>
             <a:fld id="{C1FF6DA9-008F-8B48-92A6-B652298478BF}" type="slidenum">
               <a:rPr lang="en-US" smtClean="0"/>
-              <a:t>‹#›</a:t>
+              <a:t>‹nº›</a:t>
             </a:fld>
             <a:endParaRPr lang="en-US"/>
           </a:p>
@@ -1988,7 +1988,7 @@
           <a:p>
             <a:fld id="{5BCAD085-E8A6-8845-BD4E-CB4CCA059FC4}" type="datetimeFigureOut">
               <a:rPr lang="en-US" smtClean="0"/>
-              <a:t>1/27/13</a:t>
+              <a:t>9/20/2026</a:t>
             </a:fld>
             <a:endParaRPr lang="en-US"/>
           </a:p>
@@ -2030,7 +2030,7 @@
           <a:p>
             <a:fld id="{C1FF6DA9-008F-8B48-92A6-B652298478BF}" type="slidenum">
               <a:rPr lang="en-US" smtClean="0"/>
-              <a:t>‹#›</a:t>
+              <a:t>‹nº›</a:t>
             </a:fld>
             <a:endParaRPr lang="en-US"/>
           </a:p>
@@ -2091,10 +2091,9 @@
           </a:lstStyle>
           <a:p>
             <a:r>
-              <a:rPr lang="en-US" smtClean="0"/>
+              <a:rPr lang="en-US"/>
               <a:t>Click to edit Master title style</a:t>
             </a:r>
-            <a:endParaRPr lang="en-US"/>
           </a:p>
         </p:txBody>
       </p:sp>
@@ -2148,38 +2147,37 @@
           <a:p>
             <a:pPr lvl="0"/>
             <a:r>
-              <a:rPr lang="en-US" smtClean="0"/>
+              <a:rPr lang="en-US"/>
               <a:t>Click to edit Master text styles</a:t>
             </a:r>
           </a:p>
           <a:p>
             <a:pPr lvl="1"/>
             <a:r>
-              <a:rPr lang="en-US" smtClean="0"/>
+              <a:rPr lang="en-US"/>
               <a:t>Second level</a:t>
             </a:r>
           </a:p>
           <a:p>
             <a:pPr lvl="2"/>
             <a:r>
-              <a:rPr lang="en-US" smtClean="0"/>
+              <a:rPr lang="en-US"/>
               <a:t>Third level</a:t>
             </a:r>
           </a:p>
           <a:p>
             <a:pPr lvl="3"/>
             <a:r>
-              <a:rPr lang="en-US" smtClean="0"/>
+              <a:rPr lang="en-US"/>
               <a:t>Fourth level</a:t>
             </a:r>
           </a:p>
           <a:p>
             <a:pPr lvl="4"/>
             <a:r>
-              <a:rPr lang="en-US" smtClean="0"/>
+              <a:rPr lang="en-US"/>
               <a:t>Fifth level</a:t>
             </a:r>
-            <a:endParaRPr lang="en-US"/>
           </a:p>
         </p:txBody>
       </p:sp>
@@ -2242,7 +2240,7 @@
           <a:p>
             <a:pPr lvl="0"/>
             <a:r>
-              <a:rPr lang="en-US" smtClean="0"/>
+              <a:rPr lang="en-US"/>
               <a:t>Click to edit Master text styles</a:t>
             </a:r>
           </a:p>
@@ -2265,7 +2263,7 @@
           <a:p>
             <a:fld id="{5BCAD085-E8A6-8845-BD4E-CB4CCA059FC4}" type="datetimeFigureOut">
               <a:rPr lang="en-US" smtClean="0"/>
-              <a:t>1/27/13</a:t>
+              <a:t>9/20/2026</a:t>
             </a:fld>
             <a:endParaRPr lang="en-US"/>
           </a:p>
@@ -2307,7 +2305,7 @@
           <a:p>
             <a:fld id="{C1FF6DA9-008F-8B48-92A6-B652298478BF}" type="slidenum">
               <a:rPr lang="en-US" smtClean="0"/>
-              <a:t>‹#›</a:t>
+              <a:t>‹nº›</a:t>
             </a:fld>
             <a:endParaRPr lang="en-US"/>
           </a:p>
@@ -2368,10 +2366,9 @@
           </a:lstStyle>
           <a:p>
             <a:r>
-              <a:rPr lang="en-US" smtClean="0"/>
+              <a:rPr lang="en-US"/>
               <a:t>Click to edit Master title style</a:t>
             </a:r>
-            <a:endParaRPr lang="en-US"/>
           </a:p>
         </p:txBody>
       </p:sp>
@@ -2495,7 +2492,7 @@
           <a:p>
             <a:pPr lvl="0"/>
             <a:r>
-              <a:rPr lang="en-US" smtClean="0"/>
+              <a:rPr lang="en-US"/>
               <a:t>Click to edit Master text styles</a:t>
             </a:r>
           </a:p>
@@ -2518,7 +2515,7 @@
           <a:p>
             <a:fld id="{5BCAD085-E8A6-8845-BD4E-CB4CCA059FC4}" type="datetimeFigureOut">
               <a:rPr lang="en-US" smtClean="0"/>
-              <a:t>1/27/13</a:t>
+              <a:t>9/20/2026</a:t>
             </a:fld>
             <a:endParaRPr lang="en-US"/>
           </a:p>
@@ -2560,7 +2557,7 @@
           <a:p>
             <a:fld id="{C1FF6DA9-008F-8B48-92A6-B652298478BF}" type="slidenum">
               <a:rPr lang="en-US" smtClean="0"/>
-              <a:t>‹#›</a:t>
+              <a:t>‹nº›</a:t>
             </a:fld>
             <a:endParaRPr lang="en-US"/>
           </a:p>
@@ -2627,10 +2624,9 @@
           <a:lstStyle/>
           <a:p>
             <a:r>
-              <a:rPr lang="en-US" smtClean="0"/>
+              <a:rPr lang="en-US"/>
               <a:t>Click to edit Master title style</a:t>
             </a:r>
-            <a:endParaRPr lang="en-US"/>
           </a:p>
         </p:txBody>
       </p:sp>
@@ -2661,38 +2657,37 @@
           <a:p>
             <a:pPr lvl="0"/>
             <a:r>
-              <a:rPr lang="en-US" smtClean="0"/>
+              <a:rPr lang="en-US"/>
               <a:t>Click to edit Master text styles</a:t>
             </a:r>
           </a:p>
           <a:p>
             <a:pPr lvl="1"/>
             <a:r>
-              <a:rPr lang="en-US" smtClean="0"/>
+              <a:rPr lang="en-US"/>
               <a:t>Second level</a:t>
             </a:r>
           </a:p>
           <a:p>
             <a:pPr lvl="2"/>
             <a:r>
-              <a:rPr lang="en-US" smtClean="0"/>
+              <a:rPr lang="en-US"/>
               <a:t>Third level</a:t>
             </a:r>
           </a:p>
           <a:p>
             <a:pPr lvl="3"/>
             <a:r>
-              <a:rPr lang="en-US" smtClean="0"/>
+              <a:rPr lang="en-US"/>
               <a:t>Fourth level</a:t>
             </a:r>
           </a:p>
           <a:p>
             <a:pPr lvl="4"/>
             <a:r>
-              <a:rPr lang="en-US" smtClean="0"/>
+              <a:rPr lang="en-US"/>
               <a:t>Fifth level</a:t>
             </a:r>
-            <a:endParaRPr lang="en-US"/>
           </a:p>
         </p:txBody>
       </p:sp>
@@ -2731,7 +2726,7 @@
           <a:p>
             <a:fld id="{5BCAD085-E8A6-8845-BD4E-CB4CCA059FC4}" type="datetimeFigureOut">
               <a:rPr lang="en-US" smtClean="0"/>
-              <a:t>1/27/13</a:t>
+              <a:t>9/20/2026</a:t>
             </a:fld>
             <a:endParaRPr lang="en-US"/>
           </a:p>
@@ -2809,7 +2804,7 @@
           <a:p>
             <a:fld id="{C1FF6DA9-008F-8B48-92A6-B652298478BF}" type="slidenum">
               <a:rPr lang="en-US" smtClean="0"/>
-              <a:t>‹#›</a:t>
+              <a:t>‹nº›</a:t>
             </a:fld>
             <a:endParaRPr lang="en-US"/>
           </a:p>
@@ -3090,7 +3085,7 @@
 </file>
 
 <file path=ppt/slides/slide1.xml><?xml version="1.0" encoding="utf-8"?>
-<p:sld xmlns:a="http://schemas.openxmlformats.org/drawingml/2006/main" xmlns:p="http://schemas.openxmlformats.org/presentationml/2006/main" xmlns:r="http://schemas.openxmlformats.org/officeDocument/2006/relationships">
+<p:sld xmlns:a="http://schemas.openxmlformats.org/drawingml/2006/main" xmlns:r="http://schemas.openxmlformats.org/officeDocument/2006/relationships" xmlns:p="http://schemas.openxmlformats.org/presentationml/2006/main">
   <p:cSld>
     <p:spTree>
       <p:nvGrpSpPr>
@@ -3098,7 +3093,14 @@
         <p:cNvGrpSpPr/>
         <p:nvPr/>
       </p:nvGrpSpPr>
-      <p:grpSpPr/>
+      <p:grpSpPr>
+        <a:xfrm>
+          <a:off x="0" y="0"/>
+          <a:ext cx="0" cy="0"/>
+          <a:chOff x="0" y="0"/>
+          <a:chExt cx="0" cy="0"/>
+        </a:xfrm>
+      </p:grpSpPr>
       <p:sp>
         <p:nvSpPr>
           <p:cNvPr id="2" name="Rectangle 1"/>
@@ -3139,6 +3141,7 @@
           <a:lstStyle/>
           <a:p>
             <a:pPr algn="ctr"/>
+            <a:endParaRPr/>
           </a:p>
         </p:txBody>
       </p:sp>
@@ -3151,7 +3154,7 @@
         <p:spPr>
           <a:xfrm>
             <a:off x="914400" y="2011680"/>
-            <a:ext cx="10362895" cy="3200400"/>
+            <a:ext cx="10362895" cy="2585323"/>
           </a:xfrm>
           <a:prstGeom prst="rect">
             <a:avLst/>
@@ -3172,6 +3175,7 @@
               </a:defRPr>
             </a:pPr>
             <a:r>
+              <a:rPr dirty="0"/>
               <a:t>PROBLEMA DA MOCHILA 0/1</a:t>
             </a:r>
           </a:p>
@@ -3184,8 +3188,34 @@
               </a:defRPr>
             </a:pPr>
             <a:r>
-              <a:t>Resolução por Meta-Heurísticas Local e Populacional</a:t>
-            </a:r>
+              <a:rPr dirty="0" err="1"/>
+              <a:t>Resolução</a:t>
+            </a:r>
+            <a:r>
+              <a:rPr dirty="0"/>
+              <a:t> </a:t>
+            </a:r>
+            <a:r>
+              <a:rPr dirty="0" err="1"/>
+              <a:t>por</a:t>
+            </a:r>
+            <a:r>
+              <a:rPr dirty="0"/>
+              <a:t> Meta-</a:t>
+            </a:r>
+            <a:r>
+              <a:rPr dirty="0" err="1"/>
+              <a:t>Heurísticas</a:t>
+            </a:r>
+            <a:r>
+              <a:rPr dirty="0"/>
+              <a:t> Local e </a:t>
+            </a:r>
+            <a:r>
+              <a:rPr dirty="0" err="1"/>
+              <a:t>Populacional</a:t>
+            </a:r>
+            <a:endParaRPr dirty="0"/>
           </a:p>
           <a:p>
             <a:pPr>
@@ -3196,21 +3226,119 @@
               </a:defRPr>
             </a:pPr>
             <a:r>
-              <a:t>Análise Comparativa: Busca Tabu vs Algoritmo Genético em 9 Instâncias Benchmark</a:t>
-            </a:r>
-          </a:p>
-          <a:p>
-            <a:br/>
-            <a:pPr>
-              <a:defRPr sz="1400" b="1">
+              <a:rPr dirty="0" err="1"/>
+              <a:t>Análise</a:t>
+            </a:r>
+            <a:r>
+              <a:rPr dirty="0"/>
+              <a:t> </a:t>
+            </a:r>
+            <a:r>
+              <a:rPr dirty="0" err="1"/>
+              <a:t>Comparativa</a:t>
+            </a:r>
+            <a:r>
+              <a:rPr dirty="0"/>
+              <a:t>: </a:t>
+            </a:r>
+            <a:r>
+              <a:rPr dirty="0" err="1"/>
+              <a:t>Busca</a:t>
+            </a:r>
+            <a:r>
+              <a:rPr dirty="0"/>
+              <a:t> Tabu vs </a:t>
+            </a:r>
+            <a:r>
+              <a:rPr dirty="0" err="1"/>
+              <a:t>Algoritmo</a:t>
+            </a:r>
+            <a:r>
+              <a:rPr dirty="0"/>
+              <a:t> </a:t>
+            </a:r>
+            <a:r>
+              <a:rPr dirty="0" err="1"/>
+              <a:t>Genético</a:t>
+            </a:r>
+            <a:r>
+              <a:rPr dirty="0"/>
+              <a:t> </a:t>
+            </a:r>
+            <a:r>
+              <a:rPr dirty="0" err="1"/>
+              <a:t>em</a:t>
+            </a:r>
+            <a:r>
+              <a:rPr dirty="0"/>
+              <a:t> 9 </a:t>
+            </a:r>
+            <a:r>
+              <a:rPr dirty="0" err="1"/>
+              <a:t>Instâncias</a:t>
+            </a:r>
+            <a:r>
+              <a:rPr dirty="0"/>
+              <a:t> Benchmark</a:t>
+            </a:r>
+          </a:p>
+          <a:p>
+            <a:br>
+              <a:rPr lang="pt-BR" dirty="0"/>
+            </a:br>
+            <a:br>
+              <a:rPr lang="pt-BR" dirty="0"/>
+            </a:br>
+            <a:r>
+              <a:rPr lang="pt-BR" dirty="0" err="1">
                 <a:solidFill>
-                  <a:srgbClr val="FFFFFF"/>
+                  <a:schemeClr val="bg1"/>
                 </a:solidFill>
-              </a:defRPr>
-            </a:pPr>
-            <a:r>
-              <a:t>Autor: Maycon Carpes</a:t>
-            </a:r>
+              </a:rPr>
+              <a:t>realiado</a:t>
+            </a:r>
+            <a:r>
+              <a:rPr lang="pt-BR" dirty="0">
+                <a:solidFill>
+                  <a:schemeClr val="bg1"/>
+                </a:solidFill>
+              </a:rPr>
+              <a:t> por: </a:t>
+            </a:r>
+            <a:br>
+              <a:rPr dirty="0"/>
+            </a:br>
+            <a:r>
+              <a:rPr dirty="0">
+                <a:solidFill>
+                  <a:schemeClr val="bg1"/>
+                </a:solidFill>
+              </a:rPr>
+              <a:t>Maycon Carpes</a:t>
+            </a:r>
+            <a:r>
+              <a:rPr lang="pt-BR" dirty="0">
+                <a:solidFill>
+                  <a:schemeClr val="bg1"/>
+                </a:solidFill>
+              </a:rPr>
+              <a:t> </a:t>
+            </a:r>
+          </a:p>
+          <a:p>
+            <a:r>
+              <a:rPr lang="pt-BR" dirty="0">
+                <a:solidFill>
+                  <a:schemeClr val="bg1"/>
+                </a:solidFill>
+              </a:rPr>
+              <a:t>Cauã Fortes</a:t>
+            </a:r>
+            <a:endParaRPr dirty="0">
+              <a:solidFill>
+                <a:schemeClr val="bg1"/>
+              </a:solidFill>
+            </a:endParaRPr>
           </a:p>
         </p:txBody>
       </p:sp>
@@ -3223,7 +3351,7 @@
 </file>
 
 <file path=ppt/slides/slide10.xml><?xml version="1.0" encoding="utf-8"?>
-<p:sld xmlns:a="http://schemas.openxmlformats.org/drawingml/2006/main" xmlns:p="http://schemas.openxmlformats.org/presentationml/2006/main" xmlns:r="http://schemas.openxmlformats.org/officeDocument/2006/relationships">
+<p:sld xmlns:a="http://schemas.openxmlformats.org/drawingml/2006/main" xmlns:r="http://schemas.openxmlformats.org/officeDocument/2006/relationships" xmlns:p="http://schemas.openxmlformats.org/presentationml/2006/main">
   <p:cSld>
     <p:spTree>
       <p:nvGrpSpPr>
@@ -3231,7 +3359,14 @@
         <p:cNvGrpSpPr/>
         <p:nvPr/>
       </p:nvGrpSpPr>
-      <p:grpSpPr/>
+      <p:grpSpPr>
+        <a:xfrm>
+          <a:off x="0" y="0"/>
+          <a:ext cx="0" cy="0"/>
+          <a:chOff x="0" y="0"/>
+          <a:chExt cx="0" cy="0"/>
+        </a:xfrm>
+      </p:grpSpPr>
       <p:sp>
         <p:nvSpPr>
           <p:cNvPr id="2" name="Rectangle 1"/>
@@ -3272,6 +3407,7 @@
           <a:lstStyle/>
           <a:p>
             <a:pPr algn="ctr"/>
+            <a:endParaRPr/>
           </a:p>
         </p:txBody>
       </p:sp>
@@ -3313,7 +3449,7 @@
           </a:fontRef>
         </p:style>
         <p:txBody>
-          <a:bodyPr rtlCol="0" anchor="ctr" wrap="square" lIns="731520" tIns="137160"/>
+          <a:bodyPr wrap="square" lIns="731520" tIns="137160" rtlCol="0" anchor="ctr"/>
           <a:lstStyle/>
           <a:p>
             <a:pPr algn="ctr">
@@ -3360,12 +3496,48 @@
                 <a:tableStyleId>{5C22544A-7EE6-4342-B048-85BDC9FD1C3A}</a:tableStyleId>
               </a:tblPr>
               <a:tblGrid>
-                <a:gridCol w="2286000"/>
-                <a:gridCol w="1371600"/>
-                <a:gridCol w="2011680"/>
-                <a:gridCol w="2011680"/>
-                <a:gridCol w="1645920"/>
-                <a:gridCol w="1401775"/>
+                <a:gridCol w="2286000">
+                  <a:extLst>
+                    <a:ext uri="{9D8B030D-6E8A-4147-A177-3AD203B41FA5}">
+                      <a16:colId xmlns:a16="http://schemas.microsoft.com/office/drawing/2014/main" val="20000"/>
+                    </a:ext>
+                  </a:extLst>
+                </a:gridCol>
+                <a:gridCol w="1371600">
+                  <a:extLst>
+                    <a:ext uri="{9D8B030D-6E8A-4147-A177-3AD203B41FA5}">
+                      <a16:colId xmlns:a16="http://schemas.microsoft.com/office/drawing/2014/main" val="20001"/>
+                    </a:ext>
+                  </a:extLst>
+                </a:gridCol>
+                <a:gridCol w="2011680">
+                  <a:extLst>
+                    <a:ext uri="{9D8B030D-6E8A-4147-A177-3AD203B41FA5}">
+                      <a16:colId xmlns:a16="http://schemas.microsoft.com/office/drawing/2014/main" val="20002"/>
+                    </a:ext>
+                  </a:extLst>
+                </a:gridCol>
+                <a:gridCol w="2011680">
+                  <a:extLst>
+                    <a:ext uri="{9D8B030D-6E8A-4147-A177-3AD203B41FA5}">
+                      <a16:colId xmlns:a16="http://schemas.microsoft.com/office/drawing/2014/main" val="20003"/>
+                    </a:ext>
+                  </a:extLst>
+                </a:gridCol>
+                <a:gridCol w="1645920">
+                  <a:extLst>
+                    <a:ext uri="{9D8B030D-6E8A-4147-A177-3AD203B41FA5}">
+                      <a16:colId xmlns:a16="http://schemas.microsoft.com/office/drawing/2014/main" val="20004"/>
+                    </a:ext>
+                  </a:extLst>
+                </a:gridCol>
+                <a:gridCol w="1401775">
+                  <a:extLst>
+                    <a:ext uri="{9D8B030D-6E8A-4147-A177-3AD203B41FA5}">
+                      <a16:colId xmlns:a16="http://schemas.microsoft.com/office/drawing/2014/main" val="20005"/>
+                    </a:ext>
+                  </a:extLst>
+                </a:gridCol>
               </a:tblGrid>
               <a:tr h="493776">
                 <a:tc>
@@ -3374,7 +3546,7 @@
                     <a:lstStyle/>
                     <a:p>
                       <a:pPr algn="ctr">
-                        <a:defRPr b="1" sz="1200">
+                        <a:defRPr sz="1200" b="1">
                           <a:solidFill>
                             <a:srgbClr val="FFFFFF"/>
                           </a:solidFill>
@@ -3397,7 +3569,7 @@
                     <a:lstStyle/>
                     <a:p>
                       <a:pPr algn="ctr">
-                        <a:defRPr b="1" sz="1200">
+                        <a:defRPr sz="1200" b="1">
                           <a:solidFill>
                             <a:srgbClr val="FFFFFF"/>
                           </a:solidFill>
@@ -3420,7 +3592,7 @@
                     <a:lstStyle/>
                     <a:p>
                       <a:pPr algn="ctr">
-                        <a:defRPr b="1" sz="1200">
+                        <a:defRPr sz="1200" b="1">
                           <a:solidFill>
                             <a:srgbClr val="FFFFFF"/>
                           </a:solidFill>
@@ -3443,7 +3615,7 @@
                     <a:lstStyle/>
                     <a:p>
                       <a:pPr algn="ctr">
-                        <a:defRPr b="1" sz="1200">
+                        <a:defRPr sz="1200" b="1">
                           <a:solidFill>
                             <a:srgbClr val="FFFFFF"/>
                           </a:solidFill>
@@ -3466,7 +3638,7 @@
                     <a:lstStyle/>
                     <a:p>
                       <a:pPr algn="ctr">
-                        <a:defRPr b="1" sz="1200">
+                        <a:defRPr sz="1200" b="1">
                           <a:solidFill>
                             <a:srgbClr val="FFFFFF"/>
                           </a:solidFill>
@@ -3489,7 +3661,7 @@
                     <a:lstStyle/>
                     <a:p>
                       <a:pPr algn="ctr">
-                        <a:defRPr b="1" sz="1200">
+                        <a:defRPr sz="1200" b="1">
                           <a:solidFill>
                             <a:srgbClr val="FFFFFF"/>
                           </a:solidFill>
@@ -3506,6 +3678,11 @@
                     </a:solidFill>
                   </a:tcPr>
                 </a:tc>
+                <a:extLst>
+                  <a:ext uri="{0D108BD9-81ED-4DB2-BD59-A6C34878D82A}">
+                    <a16:rowId xmlns:a16="http://schemas.microsoft.com/office/drawing/2014/main" val="10000"/>
+                  </a:ext>
+                </a:extLst>
               </a:tr>
               <a:tr h="493776">
                 <a:tc>
@@ -3622,6 +3799,11 @@
                     </a:solidFill>
                   </a:tcPr>
                 </a:tc>
+                <a:extLst>
+                  <a:ext uri="{0D108BD9-81ED-4DB2-BD59-A6C34878D82A}">
+                    <a16:rowId xmlns:a16="http://schemas.microsoft.com/office/drawing/2014/main" val="10001"/>
+                  </a:ext>
+                </a:extLst>
               </a:tr>
               <a:tr h="493776">
                 <a:tc>
@@ -3738,6 +3920,11 @@
                     </a:solidFill>
                   </a:tcPr>
                 </a:tc>
+                <a:extLst>
+                  <a:ext uri="{0D108BD9-81ED-4DB2-BD59-A6C34878D82A}">
+                    <a16:rowId xmlns:a16="http://schemas.microsoft.com/office/drawing/2014/main" val="10002"/>
+                  </a:ext>
+                </a:extLst>
               </a:tr>
               <a:tr h="493776">
                 <a:tc>
@@ -3854,6 +4041,11 @@
                     </a:solidFill>
                   </a:tcPr>
                 </a:tc>
+                <a:extLst>
+                  <a:ext uri="{0D108BD9-81ED-4DB2-BD59-A6C34878D82A}">
+                    <a16:rowId xmlns:a16="http://schemas.microsoft.com/office/drawing/2014/main" val="10003"/>
+                  </a:ext>
+                </a:extLst>
               </a:tr>
               <a:tr h="493776">
                 <a:tc>
@@ -3970,6 +4162,11 @@
                     </a:solidFill>
                   </a:tcPr>
                 </a:tc>
+                <a:extLst>
+                  <a:ext uri="{0D108BD9-81ED-4DB2-BD59-A6C34878D82A}">
+                    <a16:rowId xmlns:a16="http://schemas.microsoft.com/office/drawing/2014/main" val="10004"/>
+                  </a:ext>
+                </a:extLst>
               </a:tr>
               <a:tr h="493776">
                 <a:tc>
@@ -4086,6 +4283,11 @@
                     </a:solidFill>
                   </a:tcPr>
                 </a:tc>
+                <a:extLst>
+                  <a:ext uri="{0D108BD9-81ED-4DB2-BD59-A6C34878D82A}">
+                    <a16:rowId xmlns:a16="http://schemas.microsoft.com/office/drawing/2014/main" val="10005"/>
+                  </a:ext>
+                </a:extLst>
               </a:tr>
               <a:tr h="493776">
                 <a:tc>
@@ -4202,6 +4404,11 @@
                     </a:solidFill>
                   </a:tcPr>
                 </a:tc>
+                <a:extLst>
+                  <a:ext uri="{0D108BD9-81ED-4DB2-BD59-A6C34878D82A}">
+                    <a16:rowId xmlns:a16="http://schemas.microsoft.com/office/drawing/2014/main" val="10006"/>
+                  </a:ext>
+                </a:extLst>
               </a:tr>
               <a:tr h="493776">
                 <a:tc>
@@ -4318,6 +4525,11 @@
                     </a:solidFill>
                   </a:tcPr>
                 </a:tc>
+                <a:extLst>
+                  <a:ext uri="{0D108BD9-81ED-4DB2-BD59-A6C34878D82A}">
+                    <a16:rowId xmlns:a16="http://schemas.microsoft.com/office/drawing/2014/main" val="10007"/>
+                  </a:ext>
+                </a:extLst>
               </a:tr>
               <a:tr h="493776">
                 <a:tc>
@@ -4434,6 +4646,11 @@
                     </a:solidFill>
                   </a:tcPr>
                 </a:tc>
+                <a:extLst>
+                  <a:ext uri="{0D108BD9-81ED-4DB2-BD59-A6C34878D82A}">
+                    <a16:rowId xmlns:a16="http://schemas.microsoft.com/office/drawing/2014/main" val="10008"/>
+                  </a:ext>
+                </a:extLst>
               </a:tr>
               <a:tr h="493776">
                 <a:tc>
@@ -4550,6 +4767,11 @@
                     </a:solidFill>
                   </a:tcPr>
                 </a:tc>
+                <a:extLst>
+                  <a:ext uri="{0D108BD9-81ED-4DB2-BD59-A6C34878D82A}">
+                    <a16:rowId xmlns:a16="http://schemas.microsoft.com/office/drawing/2014/main" val="10009"/>
+                  </a:ext>
+                </a:extLst>
               </a:tr>
             </a:tbl>
           </a:graphicData>
@@ -4564,7 +4786,7 @@
 </file>
 
 <file path=ppt/slides/slide11.xml><?xml version="1.0" encoding="utf-8"?>
-<p:sld xmlns:a="http://schemas.openxmlformats.org/drawingml/2006/main" xmlns:p="http://schemas.openxmlformats.org/presentationml/2006/main" xmlns:r="http://schemas.openxmlformats.org/officeDocument/2006/relationships">
+<p:sld xmlns:a="http://schemas.openxmlformats.org/drawingml/2006/main" xmlns:r="http://schemas.openxmlformats.org/officeDocument/2006/relationships" xmlns:p="http://schemas.openxmlformats.org/presentationml/2006/main">
   <p:cSld>
     <p:spTree>
       <p:nvGrpSpPr>
@@ -4572,7 +4794,14 @@
         <p:cNvGrpSpPr/>
         <p:nvPr/>
       </p:nvGrpSpPr>
-      <p:grpSpPr/>
+      <p:grpSpPr>
+        <a:xfrm>
+          <a:off x="0" y="0"/>
+          <a:ext cx="0" cy="0"/>
+          <a:chOff x="0" y="0"/>
+          <a:chExt cx="0" cy="0"/>
+        </a:xfrm>
+      </p:grpSpPr>
       <p:sp>
         <p:nvSpPr>
           <p:cNvPr id="2" name="Rectangle 1"/>
@@ -4613,6 +4842,7 @@
           <a:lstStyle/>
           <a:p>
             <a:pPr algn="ctr"/>
+            <a:endParaRPr/>
           </a:p>
         </p:txBody>
       </p:sp>
@@ -4654,7 +4884,7 @@
           </a:fontRef>
         </p:style>
         <p:txBody>
-          <a:bodyPr rtlCol="0" anchor="ctr" wrap="square" lIns="731520" tIns="137160"/>
+          <a:bodyPr wrap="square" lIns="731520" tIns="137160" rtlCol="0" anchor="ctr"/>
           <a:lstStyle/>
           <a:p>
             <a:pPr algn="ctr">
@@ -4715,7 +4945,7 @@
           </a:fontRef>
         </p:style>
         <p:txBody>
-          <a:bodyPr rtlCol="0" anchor="ctr" wrap="square" lIns="274320" tIns="274320"/>
+          <a:bodyPr wrap="square" lIns="274320" tIns="274320" rtlCol="0" anchor="ctr"/>
           <a:lstStyle/>
           <a:p>
             <a:pPr algn="ctr">
@@ -4731,7 +4961,7 @@
           </a:p>
           <a:p>
             <a:pPr>
-              <a:defRPr b="1" sz="1300"/>
+              <a:defRPr sz="1300" b="1"/>
             </a:pPr>
             <a:r>
               <a:t>• Algoritmo Genético: </a:t>
@@ -4743,7 +4973,7 @@
           </a:p>
           <a:p>
             <a:pPr>
-              <a:defRPr b="1" sz="1300"/>
+              <a:defRPr sz="1300" b="1"/>
             </a:pPr>
             <a:r>
               <a:t>• Busca Tabu: </a:t>
@@ -4755,7 +4985,7 @@
           </a:p>
           <a:p>
             <a:pPr>
-              <a:defRPr b="1" sz="1300"/>
+              <a:defRPr sz="1300" b="1"/>
             </a:pPr>
             <a:r>
               <a:t>• Escalabilidade (100 itens): </a:t>
@@ -4800,7 +5030,7 @@
           </a:fontRef>
         </p:style>
         <p:txBody>
-          <a:bodyPr rtlCol="0" anchor="ctr" wrap="square" lIns="274320" tIns="274320"/>
+          <a:bodyPr wrap="square" lIns="274320" tIns="274320" rtlCol="0" anchor="ctr"/>
           <a:lstStyle/>
           <a:p>
             <a:pPr algn="ctr">
@@ -4816,7 +5046,7 @@
           </a:p>
           <a:p>
             <a:pPr>
-              <a:defRPr b="1" sz="1300"/>
+              <a:defRPr sz="1300" b="1"/>
             </a:pPr>
             <a:r>
               <a:t>• Velocidade da Busca Tabu: </a:t>
@@ -4828,7 +5058,7 @@
           </a:p>
           <a:p>
             <a:pPr>
-              <a:defRPr b="1" sz="1300"/>
+              <a:defRPr sz="1300" b="1"/>
             </a:pPr>
             <a:r>
               <a:t>• Poder da População no AG: </a:t>
@@ -4840,7 +5070,7 @@
           </a:p>
           <a:p>
             <a:pPr>
-              <a:defRPr b="1" sz="1300"/>
+              <a:defRPr sz="1300" b="1"/>
             </a:pPr>
             <a:r>
               <a:t>• Recomendação Final: </a:t>
@@ -4861,7 +5091,7 @@
 </file>
 
 <file path=ppt/slides/slide12.xml><?xml version="1.0" encoding="utf-8"?>
-<p:sld xmlns:a="http://schemas.openxmlformats.org/drawingml/2006/main" xmlns:p="http://schemas.openxmlformats.org/presentationml/2006/main" xmlns:r="http://schemas.openxmlformats.org/officeDocument/2006/relationships">
+<p:sld xmlns:a="http://schemas.openxmlformats.org/drawingml/2006/main" xmlns:r="http://schemas.openxmlformats.org/officeDocument/2006/relationships" xmlns:p="http://schemas.openxmlformats.org/presentationml/2006/main">
   <p:cSld>
     <p:spTree>
       <p:nvGrpSpPr>
@@ -4869,7 +5099,14 @@
         <p:cNvGrpSpPr/>
         <p:nvPr/>
       </p:nvGrpSpPr>
-      <p:grpSpPr/>
+      <p:grpSpPr>
+        <a:xfrm>
+          <a:off x="0" y="0"/>
+          <a:ext cx="0" cy="0"/>
+          <a:chOff x="0" y="0"/>
+          <a:chExt cx="0" cy="0"/>
+        </a:xfrm>
+      </p:grpSpPr>
       <p:sp>
         <p:nvSpPr>
           <p:cNvPr id="2" name="Rectangle 1"/>
@@ -4910,6 +5147,7 @@
           <a:lstStyle/>
           <a:p>
             <a:pPr algn="ctr"/>
+            <a:endParaRPr/>
           </a:p>
         </p:txBody>
       </p:sp>
@@ -4960,13 +5198,6 @@
           </a:p>
           <a:p>
             <a:br/>
-            <a:pPr algn="ctr">
-              <a:defRPr sz="1600">
-                <a:solidFill>
-                  <a:srgbClr val="C8D7F0"/>
-                </a:solidFill>
-              </a:defRPr>
-            </a:pPr>
             <a:r>
               <a:t>Repositório: github.com/MayconCarpes/Mochila01</a:t>
             </a:r>
@@ -4982,7 +5213,7 @@
 </file>
 
 <file path=ppt/slides/slide2.xml><?xml version="1.0" encoding="utf-8"?>
-<p:sld xmlns:a="http://schemas.openxmlformats.org/drawingml/2006/main" xmlns:p="http://schemas.openxmlformats.org/presentationml/2006/main" xmlns:r="http://schemas.openxmlformats.org/officeDocument/2006/relationships">
+<p:sld xmlns:a="http://schemas.openxmlformats.org/drawingml/2006/main" xmlns:r="http://schemas.openxmlformats.org/officeDocument/2006/relationships" xmlns:p="http://schemas.openxmlformats.org/presentationml/2006/main">
   <p:cSld>
     <p:spTree>
       <p:nvGrpSpPr>
@@ -4990,7 +5221,14 @@
         <p:cNvGrpSpPr/>
         <p:nvPr/>
       </p:nvGrpSpPr>
-      <p:grpSpPr/>
+      <p:grpSpPr>
+        <a:xfrm>
+          <a:off x="0" y="0"/>
+          <a:ext cx="0" cy="0"/>
+          <a:chOff x="0" y="0"/>
+          <a:chExt cx="0" cy="0"/>
+        </a:xfrm>
+      </p:grpSpPr>
       <p:sp>
         <p:nvSpPr>
           <p:cNvPr id="2" name="Rectangle 1"/>
@@ -5031,6 +5269,7 @@
           <a:lstStyle/>
           <a:p>
             <a:pPr algn="ctr"/>
+            <a:endParaRPr/>
           </a:p>
         </p:txBody>
       </p:sp>
@@ -5072,7 +5311,7 @@
           </a:fontRef>
         </p:style>
         <p:txBody>
-          <a:bodyPr rtlCol="0" anchor="ctr" wrap="square" lIns="731520" tIns="137160"/>
+          <a:bodyPr wrap="square" lIns="731520" tIns="137160" rtlCol="0" anchor="ctr"/>
           <a:lstStyle/>
           <a:p>
             <a:pPr algn="ctr">
@@ -5138,7 +5377,7 @@
           </a:fontRef>
         </p:style>
         <p:txBody>
-          <a:bodyPr rtlCol="0" anchor="ctr" wrap="square" lIns="274320" rIns="274320" tIns="274320"/>
+          <a:bodyPr wrap="square" lIns="274320" tIns="274320" rIns="274320" rtlCol="0" anchor="ctr"/>
           <a:lstStyle/>
           <a:p>
             <a:pPr algn="ctr">
@@ -5154,7 +5393,7 @@
           </a:p>
           <a:p>
             <a:pPr>
-              <a:defRPr b="1" sz="1400">
+              <a:defRPr sz="1400" b="1">
                 <a:solidFill>
                   <a:srgbClr val="1E1E1E"/>
                 </a:solidFill>
@@ -5170,7 +5409,7 @@
           </a:p>
           <a:p>
             <a:pPr>
-              <a:defRPr b="1" sz="1400">
+              <a:defRPr sz="1400" b="1">
                 <a:solidFill>
                   <a:srgbClr val="1E1E1E"/>
                 </a:solidFill>
@@ -5186,7 +5425,7 @@
           </a:p>
           <a:p>
             <a:pPr>
-              <a:defRPr b="1" sz="1400">
+              <a:defRPr sz="1400" b="1">
                 <a:solidFill>
                   <a:srgbClr val="1E1E1E"/>
                 </a:solidFill>
@@ -5202,7 +5441,7 @@
           </a:p>
           <a:p>
             <a:pPr>
-              <a:defRPr b="1" sz="1400">
+              <a:defRPr sz="1400" b="1">
                 <a:solidFill>
                   <a:srgbClr val="1E1E1E"/>
                 </a:solidFill>
@@ -5256,7 +5495,7 @@
           </a:fontRef>
         </p:style>
         <p:txBody>
-          <a:bodyPr rtlCol="0" anchor="ctr" wrap="square" lIns="274320" rIns="274320" tIns="274320"/>
+          <a:bodyPr wrap="square" lIns="274320" tIns="274320" rIns="274320" rtlCol="0" anchor="ctr"/>
           <a:lstStyle/>
           <a:p>
             <a:pPr algn="ctr">
@@ -5272,7 +5511,7 @@
           </a:p>
           <a:p>
             <a:pPr>
-              <a:defRPr b="1" sz="1400">
+              <a:defRPr sz="1400" b="1">
                 <a:solidFill>
                   <a:srgbClr val="1E1E1E"/>
                 </a:solidFill>
@@ -5290,7 +5529,7 @@
           </a:p>
           <a:p>
             <a:pPr>
-              <a:defRPr b="1" sz="1400">
+              <a:defRPr sz="1400" b="1">
                 <a:solidFill>
                   <a:srgbClr val="1E1E1E"/>
                 </a:solidFill>
@@ -5307,7 +5546,7 @@
           </a:p>
           <a:p>
             <a:pPr>
-              <a:defRPr b="1" sz="1400">
+              <a:defRPr sz="1400" b="1">
                 <a:solidFill>
                   <a:srgbClr val="1E1E1E"/>
                 </a:solidFill>
@@ -5324,7 +5563,7 @@
           </a:p>
           <a:p>
             <a:pPr>
-              <a:defRPr b="1" sz="1400">
+              <a:defRPr sz="1400" b="1">
                 <a:solidFill>
                   <a:srgbClr val="1E1E1E"/>
                 </a:solidFill>
@@ -5350,7 +5589,7 @@
 </file>
 
 <file path=ppt/slides/slide3.xml><?xml version="1.0" encoding="utf-8"?>
-<p:sld xmlns:a="http://schemas.openxmlformats.org/drawingml/2006/main" xmlns:p="http://schemas.openxmlformats.org/presentationml/2006/main" xmlns:r="http://schemas.openxmlformats.org/officeDocument/2006/relationships">
+<p:sld xmlns:a="http://schemas.openxmlformats.org/drawingml/2006/main" xmlns:r="http://schemas.openxmlformats.org/officeDocument/2006/relationships" xmlns:p="http://schemas.openxmlformats.org/presentationml/2006/main">
   <p:cSld>
     <p:spTree>
       <p:nvGrpSpPr>
@@ -5358,7 +5597,14 @@
         <p:cNvGrpSpPr/>
         <p:nvPr/>
       </p:nvGrpSpPr>
-      <p:grpSpPr/>
+      <p:grpSpPr>
+        <a:xfrm>
+          <a:off x="0" y="0"/>
+          <a:ext cx="0" cy="0"/>
+          <a:chOff x="0" y="0"/>
+          <a:chExt cx="0" cy="0"/>
+        </a:xfrm>
+      </p:grpSpPr>
       <p:sp>
         <p:nvSpPr>
           <p:cNvPr id="2" name="Rectangle 1"/>
@@ -5399,6 +5645,7 @@
           <a:lstStyle/>
           <a:p>
             <a:pPr algn="ctr"/>
+            <a:endParaRPr/>
           </a:p>
         </p:txBody>
       </p:sp>
@@ -5440,7 +5687,7 @@
           </a:fontRef>
         </p:style>
         <p:txBody>
-          <a:bodyPr rtlCol="0" anchor="ctr" wrap="square" lIns="731520" tIns="137160"/>
+          <a:bodyPr wrap="square" lIns="731520" tIns="137160" rtlCol="0" anchor="ctr"/>
           <a:lstStyle/>
           <a:p>
             <a:pPr algn="ctr">
@@ -5487,11 +5734,41 @@
                 <a:tableStyleId>{5C22544A-7EE6-4342-B048-85BDC9FD1C3A}</a:tableStyleId>
               </a:tblPr>
               <a:tblGrid>
-                <a:gridCol w="2011680"/>
-                <a:gridCol w="1645920"/>
-                <a:gridCol w="2286000"/>
-                <a:gridCol w="2286000"/>
-                <a:gridCol w="2499055"/>
+                <a:gridCol w="2011680">
+                  <a:extLst>
+                    <a:ext uri="{9D8B030D-6E8A-4147-A177-3AD203B41FA5}">
+                      <a16:colId xmlns:a16="http://schemas.microsoft.com/office/drawing/2014/main" val="20000"/>
+                    </a:ext>
+                  </a:extLst>
+                </a:gridCol>
+                <a:gridCol w="1645920">
+                  <a:extLst>
+                    <a:ext uri="{9D8B030D-6E8A-4147-A177-3AD203B41FA5}">
+                      <a16:colId xmlns:a16="http://schemas.microsoft.com/office/drawing/2014/main" val="20001"/>
+                    </a:ext>
+                  </a:extLst>
+                </a:gridCol>
+                <a:gridCol w="2286000">
+                  <a:extLst>
+                    <a:ext uri="{9D8B030D-6E8A-4147-A177-3AD203B41FA5}">
+                      <a16:colId xmlns:a16="http://schemas.microsoft.com/office/drawing/2014/main" val="20002"/>
+                    </a:ext>
+                  </a:extLst>
+                </a:gridCol>
+                <a:gridCol w="2286000">
+                  <a:extLst>
+                    <a:ext uri="{9D8B030D-6E8A-4147-A177-3AD203B41FA5}">
+                      <a16:colId xmlns:a16="http://schemas.microsoft.com/office/drawing/2014/main" val="20003"/>
+                    </a:ext>
+                  </a:extLst>
+                </a:gridCol>
+                <a:gridCol w="2499055">
+                  <a:extLst>
+                    <a:ext uri="{9D8B030D-6E8A-4147-A177-3AD203B41FA5}">
+                      <a16:colId xmlns:a16="http://schemas.microsoft.com/office/drawing/2014/main" val="20004"/>
+                    </a:ext>
+                  </a:extLst>
+                </a:gridCol>
               </a:tblGrid>
               <a:tr h="493776">
                 <a:tc>
@@ -5500,7 +5777,7 @@
                     <a:lstStyle/>
                     <a:p>
                       <a:pPr algn="ctr">
-                        <a:defRPr b="1" sz="1300">
+                        <a:defRPr sz="1300" b="1">
                           <a:solidFill>
                             <a:srgbClr val="FFFFFF"/>
                           </a:solidFill>
@@ -5523,7 +5800,7 @@
                     <a:lstStyle/>
                     <a:p>
                       <a:pPr algn="ctr">
-                        <a:defRPr b="1" sz="1300">
+                        <a:defRPr sz="1300" b="1">
                           <a:solidFill>
                             <a:srgbClr val="FFFFFF"/>
                           </a:solidFill>
@@ -5546,7 +5823,7 @@
                     <a:lstStyle/>
                     <a:p>
                       <a:pPr algn="ctr">
-                        <a:defRPr b="1" sz="1300">
+                        <a:defRPr sz="1300" b="1">
                           <a:solidFill>
                             <a:srgbClr val="FFFFFF"/>
                           </a:solidFill>
@@ -5569,7 +5846,7 @@
                     <a:lstStyle/>
                     <a:p>
                       <a:pPr algn="ctr">
-                        <a:defRPr b="1" sz="1300">
+                        <a:defRPr sz="1300" b="1">
                           <a:solidFill>
                             <a:srgbClr val="FFFFFF"/>
                           </a:solidFill>
@@ -5592,7 +5869,7 @@
                     <a:lstStyle/>
                     <a:p>
                       <a:pPr algn="ctr">
-                        <a:defRPr b="1" sz="1300">
+                        <a:defRPr sz="1300" b="1">
                           <a:solidFill>
                             <a:srgbClr val="FFFFFF"/>
                           </a:solidFill>
@@ -5609,6 +5886,11 @@
                     </a:solidFill>
                   </a:tcPr>
                 </a:tc>
+                <a:extLst>
+                  <a:ext uri="{0D108BD9-81ED-4DB2-BD59-A6C34878D82A}">
+                    <a16:rowId xmlns:a16="http://schemas.microsoft.com/office/drawing/2014/main" val="10000"/>
+                  </a:ext>
+                </a:extLst>
               </a:tr>
               <a:tr h="493776">
                 <a:tc>
@@ -5726,6 +6008,11 @@
                     </a:solidFill>
                   </a:tcPr>
                 </a:tc>
+                <a:extLst>
+                  <a:ext uri="{0D108BD9-81ED-4DB2-BD59-A6C34878D82A}">
+                    <a16:rowId xmlns:a16="http://schemas.microsoft.com/office/drawing/2014/main" val="10001"/>
+                  </a:ext>
+                </a:extLst>
               </a:tr>
               <a:tr h="493776">
                 <a:tc>
@@ -5843,6 +6130,11 @@
                     </a:solidFill>
                   </a:tcPr>
                 </a:tc>
+                <a:extLst>
+                  <a:ext uri="{0D108BD9-81ED-4DB2-BD59-A6C34878D82A}">
+                    <a16:rowId xmlns:a16="http://schemas.microsoft.com/office/drawing/2014/main" val="10002"/>
+                  </a:ext>
+                </a:extLst>
               </a:tr>
               <a:tr h="493776">
                 <a:tc>
@@ -5960,6 +6252,11 @@
                     </a:solidFill>
                   </a:tcPr>
                 </a:tc>
+                <a:extLst>
+                  <a:ext uri="{0D108BD9-81ED-4DB2-BD59-A6C34878D82A}">
+                    <a16:rowId xmlns:a16="http://schemas.microsoft.com/office/drawing/2014/main" val="10003"/>
+                  </a:ext>
+                </a:extLst>
               </a:tr>
               <a:tr h="493776">
                 <a:tc>
@@ -6077,6 +6374,11 @@
                     </a:solidFill>
                   </a:tcPr>
                 </a:tc>
+                <a:extLst>
+                  <a:ext uri="{0D108BD9-81ED-4DB2-BD59-A6C34878D82A}">
+                    <a16:rowId xmlns:a16="http://schemas.microsoft.com/office/drawing/2014/main" val="10004"/>
+                  </a:ext>
+                </a:extLst>
               </a:tr>
               <a:tr h="493776">
                 <a:tc>
@@ -6194,6 +6496,11 @@
                     </a:solidFill>
                   </a:tcPr>
                 </a:tc>
+                <a:extLst>
+                  <a:ext uri="{0D108BD9-81ED-4DB2-BD59-A6C34878D82A}">
+                    <a16:rowId xmlns:a16="http://schemas.microsoft.com/office/drawing/2014/main" val="10005"/>
+                  </a:ext>
+                </a:extLst>
               </a:tr>
               <a:tr h="493776">
                 <a:tc>
@@ -6311,6 +6618,11 @@
                     </a:solidFill>
                   </a:tcPr>
                 </a:tc>
+                <a:extLst>
+                  <a:ext uri="{0D108BD9-81ED-4DB2-BD59-A6C34878D82A}">
+                    <a16:rowId xmlns:a16="http://schemas.microsoft.com/office/drawing/2014/main" val="10006"/>
+                  </a:ext>
+                </a:extLst>
               </a:tr>
               <a:tr h="493776">
                 <a:tc>
@@ -6428,6 +6740,11 @@
                     </a:solidFill>
                   </a:tcPr>
                 </a:tc>
+                <a:extLst>
+                  <a:ext uri="{0D108BD9-81ED-4DB2-BD59-A6C34878D82A}">
+                    <a16:rowId xmlns:a16="http://schemas.microsoft.com/office/drawing/2014/main" val="10007"/>
+                  </a:ext>
+                </a:extLst>
               </a:tr>
               <a:tr h="493776">
                 <a:tc>
@@ -6545,6 +6862,11 @@
                     </a:solidFill>
                   </a:tcPr>
                 </a:tc>
+                <a:extLst>
+                  <a:ext uri="{0D108BD9-81ED-4DB2-BD59-A6C34878D82A}">
+                    <a16:rowId xmlns:a16="http://schemas.microsoft.com/office/drawing/2014/main" val="10008"/>
+                  </a:ext>
+                </a:extLst>
               </a:tr>
               <a:tr h="493776">
                 <a:tc>
@@ -6662,6 +6984,11 @@
                     </a:solidFill>
                   </a:tcPr>
                 </a:tc>
+                <a:extLst>
+                  <a:ext uri="{0D108BD9-81ED-4DB2-BD59-A6C34878D82A}">
+                    <a16:rowId xmlns:a16="http://schemas.microsoft.com/office/drawing/2014/main" val="10009"/>
+                  </a:ext>
+                </a:extLst>
               </a:tr>
             </a:tbl>
           </a:graphicData>
@@ -6676,7 +7003,7 @@
 </file>
 
 <file path=ppt/slides/slide4.xml><?xml version="1.0" encoding="utf-8"?>
-<p:sld xmlns:a="http://schemas.openxmlformats.org/drawingml/2006/main" xmlns:p="http://schemas.openxmlformats.org/presentationml/2006/main" xmlns:r="http://schemas.openxmlformats.org/officeDocument/2006/relationships">
+<p:sld xmlns:a="http://schemas.openxmlformats.org/drawingml/2006/main" xmlns:r="http://schemas.openxmlformats.org/officeDocument/2006/relationships" xmlns:p="http://schemas.openxmlformats.org/presentationml/2006/main">
   <p:cSld>
     <p:spTree>
       <p:nvGrpSpPr>
@@ -6684,7 +7011,14 @@
         <p:cNvGrpSpPr/>
         <p:nvPr/>
       </p:nvGrpSpPr>
-      <p:grpSpPr/>
+      <p:grpSpPr>
+        <a:xfrm>
+          <a:off x="0" y="0"/>
+          <a:ext cx="0" cy="0"/>
+          <a:chOff x="0" y="0"/>
+          <a:chExt cx="0" cy="0"/>
+        </a:xfrm>
+      </p:grpSpPr>
       <p:sp>
         <p:nvSpPr>
           <p:cNvPr id="2" name="Rectangle 1"/>
@@ -6725,6 +7059,7 @@
           <a:lstStyle/>
           <a:p>
             <a:pPr algn="ctr"/>
+            <a:endParaRPr/>
           </a:p>
         </p:txBody>
       </p:sp>
@@ -6766,7 +7101,7 @@
           </a:fontRef>
         </p:style>
         <p:txBody>
-          <a:bodyPr rtlCol="0" anchor="ctr" wrap="square" lIns="731520" tIns="137160"/>
+          <a:bodyPr wrap="square" lIns="731520" tIns="137160" rtlCol="0" anchor="ctr"/>
           <a:lstStyle/>
           <a:p>
             <a:pPr algn="ctr">
@@ -6832,7 +7167,7 @@
           </a:fontRef>
         </p:style>
         <p:txBody>
-          <a:bodyPr rtlCol="0" anchor="ctr" wrap="square" lIns="365760" tIns="274320"/>
+          <a:bodyPr wrap="square" lIns="365760" tIns="274320" rtlCol="0" anchor="ctr"/>
           <a:lstStyle/>
           <a:p>
             <a:pPr algn="ctr">
@@ -6848,7 +7183,7 @@
           </a:p>
           <a:p>
             <a:pPr>
-              <a:defRPr b="1" sz="1300">
+              <a:defRPr sz="1300" b="1">
                 <a:solidFill>
                   <a:srgbClr val="0078D7"/>
                 </a:solidFill>
@@ -6868,7 +7203,7 @@
           </a:p>
           <a:p>
             <a:pPr>
-              <a:defRPr b="1" sz="1300">
+              <a:defRPr sz="1300" b="1">
                 <a:solidFill>
                   <a:srgbClr val="0078D7"/>
                 </a:solidFill>
@@ -6888,7 +7223,7 @@
           </a:p>
           <a:p>
             <a:pPr>
-              <a:defRPr b="1" sz="1300">
+              <a:defRPr sz="1300" b="1">
                 <a:solidFill>
                   <a:srgbClr val="0078D7"/>
                 </a:solidFill>
@@ -6908,7 +7243,7 @@
           </a:p>
           <a:p>
             <a:pPr>
-              <a:defRPr b="1" sz="1300">
+              <a:defRPr sz="1300" b="1">
                 <a:solidFill>
                   <a:srgbClr val="0078D7"/>
                 </a:solidFill>
@@ -6928,7 +7263,7 @@
           </a:p>
           <a:p>
             <a:pPr>
-              <a:defRPr b="1" sz="1300">
+              <a:defRPr sz="1300" b="1">
                 <a:solidFill>
                   <a:srgbClr val="0078D7"/>
                 </a:solidFill>
@@ -6948,7 +7283,7 @@
           </a:p>
           <a:p>
             <a:pPr>
-              <a:defRPr b="1" sz="1300">
+              <a:defRPr sz="1300" b="1">
                 <a:solidFill>
                   <a:srgbClr val="0078D7"/>
                 </a:solidFill>
@@ -6977,7 +7312,7 @@
 </file>
 
 <file path=ppt/slides/slide5.xml><?xml version="1.0" encoding="utf-8"?>
-<p:sld xmlns:a="http://schemas.openxmlformats.org/drawingml/2006/main" xmlns:p="http://schemas.openxmlformats.org/presentationml/2006/main" xmlns:r="http://schemas.openxmlformats.org/officeDocument/2006/relationships">
+<p:sld xmlns:a="http://schemas.openxmlformats.org/drawingml/2006/main" xmlns:r="http://schemas.openxmlformats.org/officeDocument/2006/relationships" xmlns:p="http://schemas.openxmlformats.org/presentationml/2006/main">
   <p:cSld>
     <p:spTree>
       <p:nvGrpSpPr>
@@ -6985,7 +7320,14 @@
         <p:cNvGrpSpPr/>
         <p:nvPr/>
       </p:nvGrpSpPr>
-      <p:grpSpPr/>
+      <p:grpSpPr>
+        <a:xfrm>
+          <a:off x="0" y="0"/>
+          <a:ext cx="0" cy="0"/>
+          <a:chOff x="0" y="0"/>
+          <a:chExt cx="0" cy="0"/>
+        </a:xfrm>
+      </p:grpSpPr>
       <p:sp>
         <p:nvSpPr>
           <p:cNvPr id="2" name="Rectangle 1"/>
@@ -7026,6 +7368,7 @@
           <a:lstStyle/>
           <a:p>
             <a:pPr algn="ctr"/>
+            <a:endParaRPr/>
           </a:p>
         </p:txBody>
       </p:sp>
@@ -7067,7 +7410,7 @@
           </a:fontRef>
         </p:style>
         <p:txBody>
-          <a:bodyPr rtlCol="0" anchor="ctr" wrap="square" lIns="731520" tIns="137160"/>
+          <a:bodyPr wrap="square" lIns="731520" tIns="137160" rtlCol="0" anchor="ctr"/>
           <a:lstStyle/>
           <a:p>
             <a:pPr algn="ctr">
@@ -7128,7 +7471,7 @@
           </a:fontRef>
         </p:style>
         <p:txBody>
-          <a:bodyPr rtlCol="0" anchor="ctr" wrap="square" lIns="274320" tIns="274320"/>
+          <a:bodyPr wrap="square" lIns="274320" tIns="274320" rtlCol="0" anchor="ctr"/>
           <a:lstStyle/>
           <a:p>
             <a:pPr algn="ctr">
@@ -7144,7 +7487,7 @@
           </a:p>
           <a:p>
             <a:pPr>
-              <a:defRPr b="1" sz="1300"/>
+              <a:defRPr sz="1300" b="1"/>
             </a:pPr>
             <a:r>
               <a:t>• Tipo de Busca: </a:t>
@@ -7156,7 +7499,7 @@
           </a:p>
           <a:p>
             <a:pPr>
-              <a:defRPr b="1" sz="1300"/>
+              <a:defRPr sz="1300" b="1"/>
             </a:pPr>
             <a:r>
               <a:t>• Inicialização: </a:t>
@@ -7168,7 +7511,7 @@
           </a:p>
           <a:p>
             <a:pPr>
-              <a:defRPr b="1" sz="1300"/>
+              <a:defRPr sz="1300" b="1"/>
             </a:pPr>
             <a:r>
               <a:t>• Estrutura de Memória: </a:t>
@@ -7180,7 +7523,7 @@
           </a:p>
           <a:p>
             <a:pPr>
-              <a:defRPr b="1" sz="1300"/>
+              <a:defRPr sz="1300" b="1"/>
             </a:pPr>
             <a:r>
               <a:t>• Definição de Vizinhança: </a:t>
@@ -7225,7 +7568,7 @@
           </a:fontRef>
         </p:style>
         <p:txBody>
-          <a:bodyPr rtlCol="0" anchor="ctr" wrap="square" lIns="274320" tIns="274320"/>
+          <a:bodyPr wrap="square" lIns="274320" tIns="274320" rtlCol="0" anchor="ctr"/>
           <a:lstStyle/>
           <a:p>
             <a:pPr algn="ctr">
@@ -7241,7 +7584,7 @@
           </a:p>
           <a:p>
             <a:pPr>
-              <a:defRPr b="1" sz="1300"/>
+              <a:defRPr sz="1300" b="1"/>
             </a:pPr>
             <a:r>
               <a:t>• Critério de Aspiração: </a:t>
@@ -7253,7 +7596,7 @@
           </a:p>
           <a:p>
             <a:pPr>
-              <a:defRPr b="1" sz="1300"/>
+              <a:defRPr sz="1300" b="1"/>
             </a:pPr>
             <a:r>
               <a:t>• Reparo de Vizinhança: </a:t>
@@ -7265,7 +7608,7 @@
           </a:p>
           <a:p>
             <a:pPr>
-              <a:defRPr b="1" sz="1300"/>
+              <a:defRPr sz="1300" b="1"/>
             </a:pPr>
             <a:r>
               <a:t>• Critério de Parada: </a:t>
@@ -7286,7 +7629,7 @@
 </file>
 
 <file path=ppt/slides/slide6.xml><?xml version="1.0" encoding="utf-8"?>
-<p:sld xmlns:a="http://schemas.openxmlformats.org/drawingml/2006/main" xmlns:p="http://schemas.openxmlformats.org/presentationml/2006/main" xmlns:r="http://schemas.openxmlformats.org/officeDocument/2006/relationships">
+<p:sld xmlns:a="http://schemas.openxmlformats.org/drawingml/2006/main" xmlns:r="http://schemas.openxmlformats.org/officeDocument/2006/relationships" xmlns:p="http://schemas.openxmlformats.org/presentationml/2006/main">
   <p:cSld>
     <p:spTree>
       <p:nvGrpSpPr>
@@ -7294,7 +7637,14 @@
         <p:cNvGrpSpPr/>
         <p:nvPr/>
       </p:nvGrpSpPr>
-      <p:grpSpPr/>
+      <p:grpSpPr>
+        <a:xfrm>
+          <a:off x="0" y="0"/>
+          <a:ext cx="0" cy="0"/>
+          <a:chOff x="0" y="0"/>
+          <a:chExt cx="0" cy="0"/>
+        </a:xfrm>
+      </p:grpSpPr>
       <p:sp>
         <p:nvSpPr>
           <p:cNvPr id="2" name="Rectangle 1"/>
@@ -7335,6 +7685,7 @@
           <a:lstStyle/>
           <a:p>
             <a:pPr algn="ctr"/>
+            <a:endParaRPr/>
           </a:p>
         </p:txBody>
       </p:sp>
@@ -7376,7 +7727,7 @@
           </a:fontRef>
         </p:style>
         <p:txBody>
-          <a:bodyPr rtlCol="0" anchor="ctr" wrap="square" lIns="731520" tIns="137160"/>
+          <a:bodyPr wrap="square" lIns="731520" tIns="137160" rtlCol="0" anchor="ctr"/>
           <a:lstStyle/>
           <a:p>
             <a:pPr algn="ctr">
@@ -7423,9 +7774,27 @@
                 <a:tableStyleId>{5C22544A-7EE6-4342-B048-85BDC9FD1C3A}</a:tableStyleId>
               </a:tblPr>
               <a:tblGrid>
-                <a:gridCol w="3108960"/>
-                <a:gridCol w="3108960"/>
-                <a:gridCol w="3230575"/>
+                <a:gridCol w="3108960">
+                  <a:extLst>
+                    <a:ext uri="{9D8B030D-6E8A-4147-A177-3AD203B41FA5}">
+                      <a16:colId xmlns:a16="http://schemas.microsoft.com/office/drawing/2014/main" val="20000"/>
+                    </a:ext>
+                  </a:extLst>
+                </a:gridCol>
+                <a:gridCol w="3108960">
+                  <a:extLst>
+                    <a:ext uri="{9D8B030D-6E8A-4147-A177-3AD203B41FA5}">
+                      <a16:colId xmlns:a16="http://schemas.microsoft.com/office/drawing/2014/main" val="20001"/>
+                    </a:ext>
+                  </a:extLst>
+                </a:gridCol>
+                <a:gridCol w="3230575">
+                  <a:extLst>
+                    <a:ext uri="{9D8B030D-6E8A-4147-A177-3AD203B41FA5}">
+                      <a16:colId xmlns:a16="http://schemas.microsoft.com/office/drawing/2014/main" val="20002"/>
+                    </a:ext>
+                  </a:extLst>
+                </a:gridCol>
               </a:tblGrid>
               <a:tr h="960120">
                 <a:tc>
@@ -7434,7 +7803,7 @@
                     <a:lstStyle/>
                     <a:p>
                       <a:pPr algn="ctr">
-                        <a:defRPr b="1" sz="1400">
+                        <a:defRPr sz="1400" b="1">
                           <a:solidFill>
                             <a:srgbClr val="FFFFFF"/>
                           </a:solidFill>
@@ -7457,7 +7826,7 @@
                     <a:lstStyle/>
                     <a:p>
                       <a:pPr algn="ctr">
-                        <a:defRPr b="1" sz="1400">
+                        <a:defRPr sz="1400" b="1">
                           <a:solidFill>
                             <a:srgbClr val="FFFFFF"/>
                           </a:solidFill>
@@ -7480,7 +7849,7 @@
                     <a:lstStyle/>
                     <a:p>
                       <a:pPr algn="ctr">
-                        <a:defRPr b="1" sz="1400">
+                        <a:defRPr sz="1400" b="1">
                           <a:solidFill>
                             <a:srgbClr val="FFFFFF"/>
                           </a:solidFill>
@@ -7497,6 +7866,11 @@
                     </a:solidFill>
                   </a:tcPr>
                 </a:tc>
+                <a:extLst>
+                  <a:ext uri="{0D108BD9-81ED-4DB2-BD59-A6C34878D82A}">
+                    <a16:rowId xmlns:a16="http://schemas.microsoft.com/office/drawing/2014/main" val="10000"/>
+                  </a:ext>
+                </a:extLst>
               </a:tr>
               <a:tr h="960120">
                 <a:tc>
@@ -7556,6 +7930,11 @@
                     </a:solidFill>
                   </a:tcPr>
                 </a:tc>
+                <a:extLst>
+                  <a:ext uri="{0D108BD9-81ED-4DB2-BD59-A6C34878D82A}">
+                    <a16:rowId xmlns:a16="http://schemas.microsoft.com/office/drawing/2014/main" val="10001"/>
+                  </a:ext>
+                </a:extLst>
               </a:tr>
               <a:tr h="960120">
                 <a:tc>
@@ -7615,6 +7994,11 @@
                     </a:solidFill>
                   </a:tcPr>
                 </a:tc>
+                <a:extLst>
+                  <a:ext uri="{0D108BD9-81ED-4DB2-BD59-A6C34878D82A}">
+                    <a16:rowId xmlns:a16="http://schemas.microsoft.com/office/drawing/2014/main" val="10002"/>
+                  </a:ext>
+                </a:extLst>
               </a:tr>
               <a:tr h="960120">
                 <a:tc>
@@ -7674,6 +8058,11 @@
                     </a:solidFill>
                   </a:tcPr>
                 </a:tc>
+                <a:extLst>
+                  <a:ext uri="{0D108BD9-81ED-4DB2-BD59-A6C34878D82A}">
+                    <a16:rowId xmlns:a16="http://schemas.microsoft.com/office/drawing/2014/main" val="10003"/>
+                  </a:ext>
+                </a:extLst>
               </a:tr>
             </a:tbl>
           </a:graphicData>
@@ -7688,7 +8077,7 @@
 </file>
 
 <file path=ppt/slides/slide7.xml><?xml version="1.0" encoding="utf-8"?>
-<p:sld xmlns:a="http://schemas.openxmlformats.org/drawingml/2006/main" xmlns:p="http://schemas.openxmlformats.org/presentationml/2006/main" xmlns:r="http://schemas.openxmlformats.org/officeDocument/2006/relationships">
+<p:sld xmlns:a="http://schemas.openxmlformats.org/drawingml/2006/main" xmlns:r="http://schemas.openxmlformats.org/officeDocument/2006/relationships" xmlns:p="http://schemas.openxmlformats.org/presentationml/2006/main">
   <p:cSld>
     <p:spTree>
       <p:nvGrpSpPr>
@@ -7696,7 +8085,14 @@
         <p:cNvGrpSpPr/>
         <p:nvPr/>
       </p:nvGrpSpPr>
-      <p:grpSpPr/>
+      <p:grpSpPr>
+        <a:xfrm>
+          <a:off x="0" y="0"/>
+          <a:ext cx="0" cy="0"/>
+          <a:chOff x="0" y="0"/>
+          <a:chExt cx="0" cy="0"/>
+        </a:xfrm>
+      </p:grpSpPr>
       <p:sp>
         <p:nvSpPr>
           <p:cNvPr id="2" name="Rectangle 1"/>
@@ -7737,6 +8133,7 @@
           <a:lstStyle/>
           <a:p>
             <a:pPr algn="ctr"/>
+            <a:endParaRPr/>
           </a:p>
         </p:txBody>
       </p:sp>
@@ -7778,7 +8175,7 @@
           </a:fontRef>
         </p:style>
         <p:txBody>
-          <a:bodyPr rtlCol="0" anchor="ctr" wrap="square" lIns="731520" tIns="137160"/>
+          <a:bodyPr wrap="square" lIns="731520" tIns="137160" rtlCol="0" anchor="ctr"/>
           <a:lstStyle/>
           <a:p>
             <a:pPr algn="ctr">
@@ -7839,7 +8236,7 @@
           </a:fontRef>
         </p:style>
         <p:txBody>
-          <a:bodyPr rtlCol="0" anchor="ctr" wrap="square" lIns="274320" tIns="274320"/>
+          <a:bodyPr wrap="square" lIns="274320" tIns="274320" rtlCol="0" anchor="ctr"/>
           <a:lstStyle/>
           <a:p>
             <a:pPr algn="ctr">
@@ -7855,7 +8252,7 @@
           </a:p>
           <a:p>
             <a:pPr>
-              <a:defRPr b="1" sz="1300"/>
+              <a:defRPr sz="1300" b="1"/>
             </a:pPr>
             <a:r>
               <a:t>• Cromossomo: </a:t>
@@ -7867,7 +8264,7 @@
           </a:p>
           <a:p>
             <a:pPr>
-              <a:defRPr b="1" sz="1300"/>
+              <a:defRPr sz="1300" b="1"/>
             </a:pPr>
             <a:r>
               <a:t>• Inicialização: </a:t>
@@ -7879,7 +8276,7 @@
           </a:p>
           <a:p>
             <a:pPr>
-              <a:defRPr b="1" sz="1300"/>
+              <a:defRPr sz="1300" b="1"/>
             </a:pPr>
             <a:r>
               <a:t>• Seleção por Torneio: </a:t>
@@ -7891,7 +8288,7 @@
           </a:p>
           <a:p>
             <a:pPr>
-              <a:defRPr b="1" sz="1300"/>
+              <a:defRPr sz="1300" b="1"/>
             </a:pPr>
             <a:r>
               <a:t>• Crossover: </a:t>
@@ -7936,7 +8333,7 @@
           </a:fontRef>
         </p:style>
         <p:txBody>
-          <a:bodyPr rtlCol="0" anchor="ctr" wrap="square" lIns="274320" tIns="274320"/>
+          <a:bodyPr wrap="square" lIns="274320" tIns="274320" rtlCol="0" anchor="ctr"/>
           <a:lstStyle/>
           <a:p>
             <a:pPr algn="ctr">
@@ -7952,7 +8349,7 @@
           </a:p>
           <a:p>
             <a:pPr>
-              <a:defRPr b="1" sz="1300"/>
+              <a:defRPr sz="1300" b="1"/>
             </a:pPr>
             <a:r>
               <a:t>• Mutação Bit-Flip: </a:t>
@@ -7964,7 +8361,7 @@
           </a:p>
           <a:p>
             <a:pPr>
-              <a:defRPr b="1" sz="1300"/>
+              <a:defRPr sz="1300" b="1"/>
             </a:pPr>
             <a:r>
               <a:t>• Elitismo Estrito: </a:t>
@@ -7976,7 +8373,7 @@
           </a:p>
           <a:p>
             <a:pPr>
-              <a:defRPr b="1" sz="1300"/>
+              <a:defRPr sz="1300" b="1"/>
             </a:pPr>
             <a:r>
               <a:t>• Garantia de Factibilidade: </a:t>
@@ -7997,7 +8394,7 @@
 </file>
 
 <file path=ppt/slides/slide8.xml><?xml version="1.0" encoding="utf-8"?>
-<p:sld xmlns:a="http://schemas.openxmlformats.org/drawingml/2006/main" xmlns:p="http://schemas.openxmlformats.org/presentationml/2006/main" xmlns:r="http://schemas.openxmlformats.org/officeDocument/2006/relationships">
+<p:sld xmlns:a="http://schemas.openxmlformats.org/drawingml/2006/main" xmlns:r="http://schemas.openxmlformats.org/officeDocument/2006/relationships" xmlns:p="http://schemas.openxmlformats.org/presentationml/2006/main">
   <p:cSld>
     <p:spTree>
       <p:nvGrpSpPr>
@@ -8005,7 +8402,14 @@
         <p:cNvGrpSpPr/>
         <p:nvPr/>
       </p:nvGrpSpPr>
-      <p:grpSpPr/>
+      <p:grpSpPr>
+        <a:xfrm>
+          <a:off x="0" y="0"/>
+          <a:ext cx="0" cy="0"/>
+          <a:chOff x="0" y="0"/>
+          <a:chExt cx="0" cy="0"/>
+        </a:xfrm>
+      </p:grpSpPr>
       <p:sp>
         <p:nvSpPr>
           <p:cNvPr id="2" name="Rectangle 1"/>
@@ -8046,6 +8450,7 @@
           <a:lstStyle/>
           <a:p>
             <a:pPr algn="ctr"/>
+            <a:endParaRPr/>
           </a:p>
         </p:txBody>
       </p:sp>
@@ -8087,7 +8492,7 @@
           </a:fontRef>
         </p:style>
         <p:txBody>
-          <a:bodyPr rtlCol="0" anchor="ctr" wrap="square" lIns="731520" tIns="137160"/>
+          <a:bodyPr wrap="square" lIns="731520" tIns="137160" rtlCol="0" anchor="ctr"/>
           <a:lstStyle/>
           <a:p>
             <a:pPr algn="ctr">
@@ -8134,10 +8539,34 @@
                 <a:tableStyleId>{5C22544A-7EE6-4342-B048-85BDC9FD1C3A}</a:tableStyleId>
               </a:tblPr>
               <a:tblGrid>
-                <a:gridCol w="2560320"/>
-                <a:gridCol w="2560320"/>
-                <a:gridCol w="2560320"/>
-                <a:gridCol w="3047695"/>
+                <a:gridCol w="2560320">
+                  <a:extLst>
+                    <a:ext uri="{9D8B030D-6E8A-4147-A177-3AD203B41FA5}">
+                      <a16:colId xmlns:a16="http://schemas.microsoft.com/office/drawing/2014/main" val="20000"/>
+                    </a:ext>
+                  </a:extLst>
+                </a:gridCol>
+                <a:gridCol w="2560320">
+                  <a:extLst>
+                    <a:ext uri="{9D8B030D-6E8A-4147-A177-3AD203B41FA5}">
+                      <a16:colId xmlns:a16="http://schemas.microsoft.com/office/drawing/2014/main" val="20001"/>
+                    </a:ext>
+                  </a:extLst>
+                </a:gridCol>
+                <a:gridCol w="2560320">
+                  <a:extLst>
+                    <a:ext uri="{9D8B030D-6E8A-4147-A177-3AD203B41FA5}">
+                      <a16:colId xmlns:a16="http://schemas.microsoft.com/office/drawing/2014/main" val="20002"/>
+                    </a:ext>
+                  </a:extLst>
+                </a:gridCol>
+                <a:gridCol w="3047695">
+                  <a:extLst>
+                    <a:ext uri="{9D8B030D-6E8A-4147-A177-3AD203B41FA5}">
+                      <a16:colId xmlns:a16="http://schemas.microsoft.com/office/drawing/2014/main" val="20003"/>
+                    </a:ext>
+                  </a:extLst>
+                </a:gridCol>
               </a:tblGrid>
               <a:tr h="960120">
                 <a:tc>
@@ -8146,7 +8575,7 @@
                     <a:lstStyle/>
                     <a:p>
                       <a:pPr algn="ctr">
-                        <a:defRPr b="1" sz="1400">
+                        <a:defRPr sz="1400" b="1">
                           <a:solidFill>
                             <a:srgbClr val="FFFFFF"/>
                           </a:solidFill>
@@ -8169,7 +8598,7 @@
                     <a:lstStyle/>
                     <a:p>
                       <a:pPr algn="ctr">
-                        <a:defRPr b="1" sz="1400">
+                        <a:defRPr sz="1400" b="1">
                           <a:solidFill>
                             <a:srgbClr val="FFFFFF"/>
                           </a:solidFill>
@@ -8192,7 +8621,7 @@
                     <a:lstStyle/>
                     <a:p>
                       <a:pPr algn="ctr">
-                        <a:defRPr b="1" sz="1400">
+                        <a:defRPr sz="1400" b="1">
                           <a:solidFill>
                             <a:srgbClr val="FFFFFF"/>
                           </a:solidFill>
@@ -8215,7 +8644,7 @@
                     <a:lstStyle/>
                     <a:p>
                       <a:pPr algn="ctr">
-                        <a:defRPr b="1" sz="1400">
+                        <a:defRPr sz="1400" b="1">
                           <a:solidFill>
                             <a:srgbClr val="FFFFFF"/>
                           </a:solidFill>
@@ -8232,6 +8661,11 @@
                     </a:solidFill>
                   </a:tcPr>
                 </a:tc>
+                <a:extLst>
+                  <a:ext uri="{0D108BD9-81ED-4DB2-BD59-A6C34878D82A}">
+                    <a16:rowId xmlns:a16="http://schemas.microsoft.com/office/drawing/2014/main" val="10000"/>
+                  </a:ext>
+                </a:extLst>
               </a:tr>
               <a:tr h="960120">
                 <a:tc>
@@ -8310,6 +8744,11 @@
                     </a:solidFill>
                   </a:tcPr>
                 </a:tc>
+                <a:extLst>
+                  <a:ext uri="{0D108BD9-81ED-4DB2-BD59-A6C34878D82A}">
+                    <a16:rowId xmlns:a16="http://schemas.microsoft.com/office/drawing/2014/main" val="10001"/>
+                  </a:ext>
+                </a:extLst>
               </a:tr>
               <a:tr h="960120">
                 <a:tc>
@@ -8388,6 +8827,11 @@
                     </a:solidFill>
                   </a:tcPr>
                 </a:tc>
+                <a:extLst>
+                  <a:ext uri="{0D108BD9-81ED-4DB2-BD59-A6C34878D82A}">
+                    <a16:rowId xmlns:a16="http://schemas.microsoft.com/office/drawing/2014/main" val="10002"/>
+                  </a:ext>
+                </a:extLst>
               </a:tr>
               <a:tr h="960120">
                 <a:tc>
@@ -8466,6 +8910,11 @@
                     </a:solidFill>
                   </a:tcPr>
                 </a:tc>
+                <a:extLst>
+                  <a:ext uri="{0D108BD9-81ED-4DB2-BD59-A6C34878D82A}">
+                    <a16:rowId xmlns:a16="http://schemas.microsoft.com/office/drawing/2014/main" val="10003"/>
+                  </a:ext>
+                </a:extLst>
               </a:tr>
             </a:tbl>
           </a:graphicData>
@@ -8480,7 +8929,7 @@
 </file>
 
 <file path=ppt/slides/slide9.xml><?xml version="1.0" encoding="utf-8"?>
-<p:sld xmlns:a="http://schemas.openxmlformats.org/drawingml/2006/main" xmlns:p="http://schemas.openxmlformats.org/presentationml/2006/main" xmlns:r="http://schemas.openxmlformats.org/officeDocument/2006/relationships">
+<p:sld xmlns:a="http://schemas.openxmlformats.org/drawingml/2006/main" xmlns:r="http://schemas.openxmlformats.org/officeDocument/2006/relationships" xmlns:p="http://schemas.openxmlformats.org/presentationml/2006/main">
   <p:cSld>
     <p:spTree>
       <p:nvGrpSpPr>
@@ -8488,7 +8937,14 @@
         <p:cNvGrpSpPr/>
         <p:nvPr/>
       </p:nvGrpSpPr>
-      <p:grpSpPr/>
+      <p:grpSpPr>
+        <a:xfrm>
+          <a:off x="0" y="0"/>
+          <a:ext cx="0" cy="0"/>
+          <a:chOff x="0" y="0"/>
+          <a:chExt cx="0" cy="0"/>
+        </a:xfrm>
+      </p:grpSpPr>
       <p:sp>
         <p:nvSpPr>
           <p:cNvPr id="2" name="Rectangle 1"/>
@@ -8529,6 +8985,7 @@
           <a:lstStyle/>
           <a:p>
             <a:pPr algn="ctr"/>
+            <a:endParaRPr/>
           </a:p>
         </p:txBody>
       </p:sp>
@@ -8570,7 +9027,7 @@
           </a:fontRef>
         </p:style>
         <p:txBody>
-          <a:bodyPr rtlCol="0" anchor="ctr" wrap="square" lIns="731520" tIns="137160"/>
+          <a:bodyPr wrap="square" lIns="731520" tIns="137160" rtlCol="0" anchor="ctr"/>
           <a:lstStyle/>
           <a:p>
             <a:pPr algn="ctr">
@@ -8617,13 +9074,55 @@
                 <a:tableStyleId>{5C22544A-7EE6-4342-B048-85BDC9FD1C3A}</a:tableStyleId>
               </a:tblPr>
               <a:tblGrid>
-                <a:gridCol w="2011680"/>
-                <a:gridCol w="1005840"/>
-                <a:gridCol w="1828800"/>
-                <a:gridCol w="1828800"/>
-                <a:gridCol w="1463040"/>
-                <a:gridCol w="1737360"/>
-                <a:gridCol w="1401775"/>
+                <a:gridCol w="2011680">
+                  <a:extLst>
+                    <a:ext uri="{9D8B030D-6E8A-4147-A177-3AD203B41FA5}">
+                      <a16:colId xmlns:a16="http://schemas.microsoft.com/office/drawing/2014/main" val="20000"/>
+                    </a:ext>
+                  </a:extLst>
+                </a:gridCol>
+                <a:gridCol w="1005840">
+                  <a:extLst>
+                    <a:ext uri="{9D8B030D-6E8A-4147-A177-3AD203B41FA5}">
+                      <a16:colId xmlns:a16="http://schemas.microsoft.com/office/drawing/2014/main" val="20001"/>
+                    </a:ext>
+                  </a:extLst>
+                </a:gridCol>
+                <a:gridCol w="1828800">
+                  <a:extLst>
+                    <a:ext uri="{9D8B030D-6E8A-4147-A177-3AD203B41FA5}">
+                      <a16:colId xmlns:a16="http://schemas.microsoft.com/office/drawing/2014/main" val="20002"/>
+                    </a:ext>
+                  </a:extLst>
+                </a:gridCol>
+                <a:gridCol w="1828800">
+                  <a:extLst>
+                    <a:ext uri="{9D8B030D-6E8A-4147-A177-3AD203B41FA5}">
+                      <a16:colId xmlns:a16="http://schemas.microsoft.com/office/drawing/2014/main" val="20003"/>
+                    </a:ext>
+                  </a:extLst>
+                </a:gridCol>
+                <a:gridCol w="1463040">
+                  <a:extLst>
+                    <a:ext uri="{9D8B030D-6E8A-4147-A177-3AD203B41FA5}">
+                      <a16:colId xmlns:a16="http://schemas.microsoft.com/office/drawing/2014/main" val="20004"/>
+                    </a:ext>
+                  </a:extLst>
+                </a:gridCol>
+                <a:gridCol w="1737360">
+                  <a:extLst>
+                    <a:ext uri="{9D8B030D-6E8A-4147-A177-3AD203B41FA5}">
+                      <a16:colId xmlns:a16="http://schemas.microsoft.com/office/drawing/2014/main" val="20005"/>
+                    </a:ext>
+                  </a:extLst>
+                </a:gridCol>
+                <a:gridCol w="1401775">
+                  <a:extLst>
+                    <a:ext uri="{9D8B030D-6E8A-4147-A177-3AD203B41FA5}">
+                      <a16:colId xmlns:a16="http://schemas.microsoft.com/office/drawing/2014/main" val="20006"/>
+                    </a:ext>
+                  </a:extLst>
+                </a:gridCol>
               </a:tblGrid>
               <a:tr h="512064">
                 <a:tc>
@@ -8632,7 +9131,7 @@
                     <a:lstStyle/>
                     <a:p>
                       <a:pPr algn="ctr">
-                        <a:defRPr b="1" sz="1200">
+                        <a:defRPr sz="1200" b="1">
                           <a:solidFill>
                             <a:srgbClr val="FFFFFF"/>
                           </a:solidFill>
@@ -8655,7 +9154,7 @@
                     <a:lstStyle/>
                     <a:p>
                       <a:pPr algn="ctr">
-                        <a:defRPr b="1" sz="1200">
+                        <a:defRPr sz="1200" b="1">
                           <a:solidFill>
                             <a:srgbClr val="FFFFFF"/>
                           </a:solidFill>
@@ -8678,7 +9177,7 @@
                     <a:lstStyle/>
                     <a:p>
                       <a:pPr algn="ctr">
-                        <a:defRPr b="1" sz="1200">
+                        <a:defRPr sz="1200" b="1">
                           <a:solidFill>
                             <a:srgbClr val="FFFFFF"/>
                           </a:solidFill>
@@ -8701,7 +9200,7 @@
                     <a:lstStyle/>
                     <a:p>
                       <a:pPr algn="ctr">
-                        <a:defRPr b="1" sz="1200">
+                        <a:defRPr sz="1200" b="1">
                           <a:solidFill>
                             <a:srgbClr val="FFFFFF"/>
                           </a:solidFill>
@@ -8724,7 +9223,7 @@
                     <a:lstStyle/>
                     <a:p>
                       <a:pPr algn="ctr">
-                        <a:defRPr b="1" sz="1200">
+                        <a:defRPr sz="1200" b="1">
                           <a:solidFill>
                             <a:srgbClr val="FFFFFF"/>
                           </a:solidFill>
@@ -8747,7 +9246,7 @@
                     <a:lstStyle/>
                     <a:p>
                       <a:pPr algn="ctr">
-                        <a:defRPr b="1" sz="1200">
+                        <a:defRPr sz="1200" b="1">
                           <a:solidFill>
                             <a:srgbClr val="FFFFFF"/>
                           </a:solidFill>
@@ -8770,7 +9269,7 @@
                     <a:lstStyle/>
                     <a:p>
                       <a:pPr algn="ctr">
-                        <a:defRPr b="1" sz="1200">
+                        <a:defRPr sz="1200" b="1">
                           <a:solidFill>
                             <a:srgbClr val="FFFFFF"/>
                           </a:solidFill>
@@ -8787,6 +9286,11 @@
                     </a:solidFill>
                   </a:tcPr>
                 </a:tc>
+                <a:extLst>
+                  <a:ext uri="{0D108BD9-81ED-4DB2-BD59-A6C34878D82A}">
+                    <a16:rowId xmlns:a16="http://schemas.microsoft.com/office/drawing/2014/main" val="10000"/>
+                  </a:ext>
+                </a:extLst>
               </a:tr>
               <a:tr h="512064">
                 <a:tc>
@@ -8930,6 +9434,11 @@
                     </a:solidFill>
                   </a:tcPr>
                 </a:tc>
+                <a:extLst>
+                  <a:ext uri="{0D108BD9-81ED-4DB2-BD59-A6C34878D82A}">
+                    <a16:rowId xmlns:a16="http://schemas.microsoft.com/office/drawing/2014/main" val="10001"/>
+                  </a:ext>
+                </a:extLst>
               </a:tr>
               <a:tr h="512064">
                 <a:tc>
@@ -9073,6 +9582,11 @@
                     </a:solidFill>
                   </a:tcPr>
                 </a:tc>
+                <a:extLst>
+                  <a:ext uri="{0D108BD9-81ED-4DB2-BD59-A6C34878D82A}">
+                    <a16:rowId xmlns:a16="http://schemas.microsoft.com/office/drawing/2014/main" val="10002"/>
+                  </a:ext>
+                </a:extLst>
               </a:tr>
               <a:tr h="512064">
                 <a:tc>
@@ -9216,6 +9730,11 @@
                     </a:solidFill>
                   </a:tcPr>
                 </a:tc>
+                <a:extLst>
+                  <a:ext uri="{0D108BD9-81ED-4DB2-BD59-A6C34878D82A}">
+                    <a16:rowId xmlns:a16="http://schemas.microsoft.com/office/drawing/2014/main" val="10003"/>
+                  </a:ext>
+                </a:extLst>
               </a:tr>
               <a:tr h="512064">
                 <a:tc>
@@ -9359,6 +9878,11 @@
                     </a:solidFill>
                   </a:tcPr>
                 </a:tc>
+                <a:extLst>
+                  <a:ext uri="{0D108BD9-81ED-4DB2-BD59-A6C34878D82A}">
+                    <a16:rowId xmlns:a16="http://schemas.microsoft.com/office/drawing/2014/main" val="10004"/>
+                  </a:ext>
+                </a:extLst>
               </a:tr>
               <a:tr h="512064">
                 <a:tc>
@@ -9502,6 +10026,11 @@
                     </a:solidFill>
                   </a:tcPr>
                 </a:tc>
+                <a:extLst>
+                  <a:ext uri="{0D108BD9-81ED-4DB2-BD59-A6C34878D82A}">
+                    <a16:rowId xmlns:a16="http://schemas.microsoft.com/office/drawing/2014/main" val="10005"/>
+                  </a:ext>
+                </a:extLst>
               </a:tr>
               <a:tr h="512064">
                 <a:tc>
@@ -9645,6 +10174,11 @@
                     </a:solidFill>
                   </a:tcPr>
                 </a:tc>
+                <a:extLst>
+                  <a:ext uri="{0D108BD9-81ED-4DB2-BD59-A6C34878D82A}">
+                    <a16:rowId xmlns:a16="http://schemas.microsoft.com/office/drawing/2014/main" val="10006"/>
+                  </a:ext>
+                </a:extLst>
               </a:tr>
               <a:tr h="512064">
                 <a:tc>
@@ -9788,6 +10322,11 @@
                     </a:solidFill>
                   </a:tcPr>
                 </a:tc>
+                <a:extLst>
+                  <a:ext uri="{0D108BD9-81ED-4DB2-BD59-A6C34878D82A}">
+                    <a16:rowId xmlns:a16="http://schemas.microsoft.com/office/drawing/2014/main" val="10007"/>
+                  </a:ext>
+                </a:extLst>
               </a:tr>
               <a:tr h="512064">
                 <a:tc>
@@ -9931,6 +10470,11 @@
                     </a:solidFill>
                   </a:tcPr>
                 </a:tc>
+                <a:extLst>
+                  <a:ext uri="{0D108BD9-81ED-4DB2-BD59-A6C34878D82A}">
+                    <a16:rowId xmlns:a16="http://schemas.microsoft.com/office/drawing/2014/main" val="10008"/>
+                  </a:ext>
+                </a:extLst>
               </a:tr>
               <a:tr h="512064">
                 <a:tc>
@@ -10074,6 +10618,11 @@
                     </a:solidFill>
                   </a:tcPr>
                 </a:tc>
+                <a:extLst>
+                  <a:ext uri="{0D108BD9-81ED-4DB2-BD59-A6C34878D82A}">
+                    <a16:rowId xmlns:a16="http://schemas.microsoft.com/office/drawing/2014/main" val="10009"/>
+                  </a:ext>
+                </a:extLst>
               </a:tr>
             </a:tbl>
           </a:graphicData>

</xml_diff>

<commit_message>
Nova alteracao do arquivo de apresentacao PowerPoint (.pptx)
</commit_message>
<xml_diff>
--- a/Mochila01_MetaHeuristicas_TabuVsAG.pptx
+++ b/Mochila01_MetaHeuristicas_TabuVsAG.pptx
@@ -3154,7 +3154,7 @@
         <p:spPr>
           <a:xfrm>
             <a:off x="914400" y="2011680"/>
-            <a:ext cx="10362895" cy="2585323"/>
+            <a:ext cx="10362895" cy="1754326"/>
           </a:xfrm>
           <a:prstGeom prst="rect">
             <a:avLst/>
@@ -3284,18 +3284,19 @@
           </a:p>
           <a:p>
             <a:br>
-              <a:rPr lang="pt-BR" dirty="0"/>
-            </a:br>
-            <a:br>
-              <a:rPr lang="pt-BR" dirty="0"/>
-            </a:br>
-            <a:r>
-              <a:rPr lang="pt-BR" dirty="0" err="1">
+              <a:rPr dirty="0">
                 <a:solidFill>
                   <a:schemeClr val="bg1"/>
                 </a:solidFill>
               </a:rPr>
-              <a:t>realiado</a:t>
+            </a:br>
+            <a:r>
+              <a:rPr dirty="0">
+                <a:solidFill>
+                  <a:schemeClr val="bg1"/>
+                </a:solidFill>
+              </a:rPr>
+              <a:t>Autor: Maycon Carpes</a:t>
             </a:r>
             <a:r>
               <a:rPr lang="pt-BR" dirty="0">
@@ -3303,36 +3304,7 @@
                   <a:schemeClr val="bg1"/>
                 </a:solidFill>
               </a:rPr>
-              <a:t> por: </a:t>
-            </a:r>
-            <a:br>
-              <a:rPr dirty="0"/>
-            </a:br>
-            <a:r>
-              <a:rPr dirty="0">
-                <a:solidFill>
-                  <a:schemeClr val="bg1"/>
-                </a:solidFill>
-              </a:rPr>
-              <a:t>Maycon Carpes</a:t>
-            </a:r>
-            <a:r>
-              <a:rPr lang="pt-BR" dirty="0">
-                <a:solidFill>
-                  <a:schemeClr val="bg1"/>
-                </a:solidFill>
-              </a:rPr>
-              <a:t> </a:t>
-            </a:r>
-          </a:p>
-          <a:p>
-            <a:r>
-              <a:rPr lang="pt-BR" dirty="0">
-                <a:solidFill>
-                  <a:schemeClr val="bg1"/>
-                </a:solidFill>
-              </a:rPr>
-              <a:t>Cauã Fortes</a:t>
+              <a:t> e Cauã Fortes</a:t>
             </a:r>
             <a:endParaRPr dirty="0">
               <a:solidFill>

</xml_diff>